<commit_message>
changed one occurrence of jest to vitest
</commit_message>
<xml_diff>
--- a/Slides/Module 09 Code Level Design.pptx
+++ b/Slides/Module 09 Code Level Design.pptx
@@ -158,1647 +158,27 @@
 </p:presentation>
 </file>
 
-<file path=ppt/revisionInfo.xml><?xml version="1.0" encoding="utf-8"?>
-<p1510:revInfo xmlns:a="http://schemas.openxmlformats.org/drawingml/2006/main" xmlns:r="http://schemas.openxmlformats.org/officeDocument/2006/relationships" xmlns:p1510="http://schemas.microsoft.com/office/powerpoint/2015/10/main">
-  <p1510:revLst>
-    <p1510:client id="{D78B7B3A-D6AA-410A-8F9F-ED7CF0BCC52D}" v="70" dt="2024-09-09T16:59:10.387"/>
-  </p1510:revLst>
-</p1510:revInfo>
-</file>
-
 <file path=ppt/changesInfos/changesInfo1.xml><?xml version="1.0" encoding="utf-8"?>
 <pc:chgInfo xmlns:a="http://schemas.openxmlformats.org/drawingml/2006/main" xmlns:r="http://schemas.openxmlformats.org/officeDocument/2006/relationships" xmlns:ac="http://schemas.microsoft.com/office/drawing/2013/main/command" xmlns:pc="http://schemas.microsoft.com/office/powerpoint/2013/main/command">
   <pc:docChgLst>
-    <pc:chgData name="Mitchell Wand" userId="de9b44c55c049659" providerId="LiveId" clId="{2BA72CEE-D8AF-4202-81F7-35E78AA5F01B}"/>
+    <pc:chgData name="Mitchell Wand" userId="de9b44c55c049659" providerId="LiveId" clId="{7A9D5940-B2CC-47DD-AF5E-71219F1A1E26}"/>
     <pc:docChg chg="modSld">
-      <pc:chgData name="Mitchell Wand" userId="de9b44c55c049659" providerId="LiveId" clId="{2BA72CEE-D8AF-4202-81F7-35E78AA5F01B}" dt="2024-01-18T02:51:12.147" v="1" actId="20577"/>
+      <pc:chgData name="Mitchell Wand" userId="de9b44c55c049659" providerId="LiveId" clId="{7A9D5940-B2CC-47DD-AF5E-71219F1A1E26}" dt="2026-09-29T00:17:24.624" v="12" actId="20577"/>
       <pc:docMkLst>
         <pc:docMk/>
       </pc:docMkLst>
-      <pc:sldChg chg="modSp mod">
-        <pc:chgData name="Mitchell Wand" userId="de9b44c55c049659" providerId="LiveId" clId="{2BA72CEE-D8AF-4202-81F7-35E78AA5F01B}" dt="2024-01-18T02:51:12.147" v="1" actId="20577"/>
-        <pc:sldMkLst>
-          <pc:docMk/>
-          <pc:sldMk cId="2452429264" sldId="379"/>
-        </pc:sldMkLst>
-        <pc:spChg chg="mod">
-          <ac:chgData name="Mitchell Wand" userId="de9b44c55c049659" providerId="LiveId" clId="{2BA72CEE-D8AF-4202-81F7-35E78AA5F01B}" dt="2024-01-18T02:51:12.147" v="1" actId="20577"/>
-          <ac:spMkLst>
-            <pc:docMk/>
-            <pc:sldMk cId="2452429264" sldId="379"/>
-            <ac:spMk id="2" creationId="{40765BC5-92E6-4F5A-B981-1C5EE975861B}"/>
-          </ac:spMkLst>
-        </pc:spChg>
-      </pc:sldChg>
-    </pc:docChg>
-  </pc:docChgLst>
-  <pc:docChgLst>
-    <pc:chgData name="Mitchell Wand" userId="de9b44c55c049659" providerId="LiveId" clId="{72A1DAB3-1E5C-4A0A-B264-8A9F09378F93}"/>
-    <pc:docChg chg="custSel modSld">
-      <pc:chgData name="Mitchell Wand" userId="de9b44c55c049659" providerId="LiveId" clId="{72A1DAB3-1E5C-4A0A-B264-8A9F09378F93}" dt="2023-08-28T15:44:31.856" v="374" actId="20577"/>
-      <pc:docMkLst>
-        <pc:docMk/>
-      </pc:docMkLst>
-      <pc:sldChg chg="modNotesTx">
-        <pc:chgData name="Mitchell Wand" userId="de9b44c55c049659" providerId="LiveId" clId="{72A1DAB3-1E5C-4A0A-B264-8A9F09378F93}" dt="2023-08-28T15:37:35.104" v="147" actId="20577"/>
-        <pc:sldMkLst>
-          <pc:docMk/>
-          <pc:sldMk cId="2175689014" sldId="363"/>
-        </pc:sldMkLst>
-      </pc:sldChg>
       <pc:sldChg chg="modSp mod modNotesTx">
-        <pc:chgData name="Mitchell Wand" userId="de9b44c55c049659" providerId="LiveId" clId="{72A1DAB3-1E5C-4A0A-B264-8A9F09378F93}" dt="2023-08-28T15:39:52.139" v="263" actId="20577"/>
-        <pc:sldMkLst>
-          <pc:docMk/>
-          <pc:sldMk cId="3947735393" sldId="365"/>
-        </pc:sldMkLst>
-        <pc:spChg chg="mod">
-          <ac:chgData name="Mitchell Wand" userId="de9b44c55c049659" providerId="LiveId" clId="{72A1DAB3-1E5C-4A0A-B264-8A9F09378F93}" dt="2023-08-28T15:39:18.085" v="216" actId="14100"/>
-          <ac:spMkLst>
-            <pc:docMk/>
-            <pc:sldMk cId="3947735393" sldId="365"/>
-            <ac:spMk id="7" creationId="{A694B6C8-5A57-35D8-E740-C16FA3796D1E}"/>
-          </ac:spMkLst>
-        </pc:spChg>
-      </pc:sldChg>
-      <pc:sldChg chg="modNotesTx">
-        <pc:chgData name="Mitchell Wand" userId="de9b44c55c049659" providerId="LiveId" clId="{72A1DAB3-1E5C-4A0A-B264-8A9F09378F93}" dt="2023-08-28T15:44:31.856" v="374" actId="20577"/>
-        <pc:sldMkLst>
-          <pc:docMk/>
-          <pc:sldMk cId="2659888623" sldId="375"/>
-        </pc:sldMkLst>
-      </pc:sldChg>
-      <pc:sldChg chg="modNotesTx">
-        <pc:chgData name="Mitchell Wand" userId="de9b44c55c049659" providerId="LiveId" clId="{72A1DAB3-1E5C-4A0A-B264-8A9F09378F93}" dt="2023-08-28T15:34:22.498" v="63" actId="20577"/>
-        <pc:sldMkLst>
-          <pc:docMk/>
-          <pc:sldMk cId="4257474872" sldId="381"/>
-        </pc:sldMkLst>
-      </pc:sldChg>
-    </pc:docChg>
-  </pc:docChgLst>
-  <pc:docChgLst>
-    <pc:chgData name="Mitchell Wand" userId="de9b44c55c049659" providerId="LiveId" clId="{EA4C50BF-E095-43E6-81D2-CD7A37F76019}"/>
-    <pc:docChg chg="undo custSel addSld delSld modSld sldOrd">
-      <pc:chgData name="Mitchell Wand" userId="de9b44c55c049659" providerId="LiveId" clId="{EA4C50BF-E095-43E6-81D2-CD7A37F76019}" dt="2022-08-30T20:37:25.081" v="1878" actId="2696"/>
-      <pc:docMkLst>
-        <pc:docMk/>
-      </pc:docMkLst>
-      <pc:sldChg chg="del">
-        <pc:chgData name="Mitchell Wand" userId="de9b44c55c049659" providerId="LiveId" clId="{EA4C50BF-E095-43E6-81D2-CD7A37F76019}" dt="2022-08-30T20:37:25.081" v="1878" actId="2696"/>
-        <pc:sldMkLst>
-          <pc:docMk/>
-          <pc:sldMk cId="1283065509" sldId="274"/>
-        </pc:sldMkLst>
-      </pc:sldChg>
-      <pc:sldChg chg="addSp modSp">
-        <pc:chgData name="Mitchell Wand" userId="de9b44c55c049659" providerId="LiveId" clId="{EA4C50BF-E095-43E6-81D2-CD7A37F76019}" dt="2022-08-30T18:56:39.833" v="5"/>
-        <pc:sldMkLst>
-          <pc:docMk/>
-          <pc:sldMk cId="3915051007" sldId="302"/>
-        </pc:sldMkLst>
-        <pc:spChg chg="add mod">
-          <ac:chgData name="Mitchell Wand" userId="de9b44c55c049659" providerId="LiveId" clId="{EA4C50BF-E095-43E6-81D2-CD7A37F76019}" dt="2022-08-30T18:56:39.833" v="5"/>
-          <ac:spMkLst>
-            <pc:docMk/>
-            <pc:sldMk cId="3915051007" sldId="302"/>
-            <ac:spMk id="4" creationId="{9BB6A7E9-D030-E1C7-FE00-AFC5225AE231}"/>
-          </ac:spMkLst>
-        </pc:spChg>
-      </pc:sldChg>
-      <pc:sldChg chg="modSp mod">
-        <pc:chgData name="Mitchell Wand" userId="de9b44c55c049659" providerId="LiveId" clId="{EA4C50BF-E095-43E6-81D2-CD7A37F76019}" dt="2022-08-30T18:58:57.892" v="138" actId="6549"/>
-        <pc:sldMkLst>
-          <pc:docMk/>
-          <pc:sldMk cId="0" sldId="351"/>
-        </pc:sldMkLst>
-        <pc:spChg chg="mod">
-          <ac:chgData name="Mitchell Wand" userId="de9b44c55c049659" providerId="LiveId" clId="{EA4C50BF-E095-43E6-81D2-CD7A37F76019}" dt="2022-08-30T18:58:57.892" v="138" actId="6549"/>
-          <ac:spMkLst>
-            <pc:docMk/>
-            <pc:sldMk cId="0" sldId="351"/>
-            <ac:spMk id="5121" creationId="{FCD54966-636B-40B8-9A0B-F5A7E500E446}"/>
-          </ac:spMkLst>
-        </pc:spChg>
-      </pc:sldChg>
-      <pc:sldChg chg="modSp mod ord">
-        <pc:chgData name="Mitchell Wand" userId="de9b44c55c049659" providerId="LiveId" clId="{EA4C50BF-E095-43E6-81D2-CD7A37F76019}" dt="2022-08-30T19:38:04.791" v="1724" actId="20577"/>
-        <pc:sldMkLst>
-          <pc:docMk/>
-          <pc:sldMk cId="3033459956" sldId="353"/>
-        </pc:sldMkLst>
-        <pc:spChg chg="mod">
-          <ac:chgData name="Mitchell Wand" userId="de9b44c55c049659" providerId="LiveId" clId="{EA4C50BF-E095-43E6-81D2-CD7A37F76019}" dt="2022-08-30T19:38:04.791" v="1724" actId="20577"/>
-          <ac:spMkLst>
-            <pc:docMk/>
-            <pc:sldMk cId="3033459956" sldId="353"/>
-            <ac:spMk id="2" creationId="{3821F185-60B9-4A8A-ACEC-EA4C06C9E0CE}"/>
-          </ac:spMkLst>
-        </pc:spChg>
-      </pc:sldChg>
-      <pc:sldChg chg="addSp modSp mod">
-        <pc:chgData name="Mitchell Wand" userId="de9b44c55c049659" providerId="LiveId" clId="{EA4C50BF-E095-43E6-81D2-CD7A37F76019}" dt="2022-08-30T18:56:30.291" v="4" actId="1076"/>
-        <pc:sldMkLst>
-          <pc:docMk/>
-          <pc:sldMk cId="986787541" sldId="355"/>
-        </pc:sldMkLst>
-        <pc:spChg chg="add mod">
-          <ac:chgData name="Mitchell Wand" userId="de9b44c55c049659" providerId="LiveId" clId="{EA4C50BF-E095-43E6-81D2-CD7A37F76019}" dt="2022-08-30T18:56:30.291" v="4" actId="1076"/>
-          <ac:spMkLst>
-            <pc:docMk/>
-            <pc:sldMk cId="986787541" sldId="355"/>
-            <ac:spMk id="5" creationId="{C261489F-F9C0-1D8F-917D-67EA130F0AA5}"/>
-          </ac:spMkLst>
-        </pc:spChg>
-      </pc:sldChg>
-      <pc:sldChg chg="modSp mod">
-        <pc:chgData name="Mitchell Wand" userId="de9b44c55c049659" providerId="LiveId" clId="{EA4C50BF-E095-43E6-81D2-CD7A37F76019}" dt="2022-08-30T19:38:36.979" v="1728" actId="20577"/>
-        <pc:sldMkLst>
-          <pc:docMk/>
-          <pc:sldMk cId="915762083" sldId="361"/>
-        </pc:sldMkLst>
-        <pc:spChg chg="mod">
-          <ac:chgData name="Mitchell Wand" userId="de9b44c55c049659" providerId="LiveId" clId="{EA4C50BF-E095-43E6-81D2-CD7A37F76019}" dt="2022-08-30T19:38:36.979" v="1728" actId="20577"/>
-          <ac:spMkLst>
-            <pc:docMk/>
-            <pc:sldMk cId="915762083" sldId="361"/>
-            <ac:spMk id="2" creationId="{3DC7B7B5-A20E-4BFB-BD45-8DC608B0560E}"/>
-          </ac:spMkLst>
-        </pc:spChg>
-      </pc:sldChg>
-      <pc:sldChg chg="modSp mod">
-        <pc:chgData name="Mitchell Wand" userId="de9b44c55c049659" providerId="LiveId" clId="{EA4C50BF-E095-43E6-81D2-CD7A37F76019}" dt="2022-08-30T19:38:41.821" v="1732" actId="20577"/>
-        <pc:sldMkLst>
-          <pc:docMk/>
-          <pc:sldMk cId="3247464670" sldId="362"/>
-        </pc:sldMkLst>
-        <pc:spChg chg="mod">
-          <ac:chgData name="Mitchell Wand" userId="de9b44c55c049659" providerId="LiveId" clId="{EA4C50BF-E095-43E6-81D2-CD7A37F76019}" dt="2022-08-30T19:38:41.821" v="1732" actId="20577"/>
-          <ac:spMkLst>
-            <pc:docMk/>
-            <pc:sldMk cId="3247464670" sldId="362"/>
-            <ac:spMk id="2" creationId="{C756854A-BE1D-42CD-B723-1DA903E0D12B}"/>
-          </ac:spMkLst>
-        </pc:spChg>
-      </pc:sldChg>
-      <pc:sldChg chg="modSp mod">
-        <pc:chgData name="Mitchell Wand" userId="de9b44c55c049659" providerId="LiveId" clId="{EA4C50BF-E095-43E6-81D2-CD7A37F76019}" dt="2022-08-30T19:38:47.917" v="1736" actId="20577"/>
-        <pc:sldMkLst>
-          <pc:docMk/>
-          <pc:sldMk cId="2175689014" sldId="363"/>
-        </pc:sldMkLst>
-        <pc:spChg chg="mod">
-          <ac:chgData name="Mitchell Wand" userId="de9b44c55c049659" providerId="LiveId" clId="{EA4C50BF-E095-43E6-81D2-CD7A37F76019}" dt="2022-08-30T19:38:47.917" v="1736" actId="20577"/>
-          <ac:spMkLst>
-            <pc:docMk/>
-            <pc:sldMk cId="2175689014" sldId="363"/>
-            <ac:spMk id="2" creationId="{E96C7083-5B57-44C3-A19B-EF3066FD0105}"/>
-          </ac:spMkLst>
-        </pc:spChg>
-      </pc:sldChg>
-      <pc:sldChg chg="modSp mod">
-        <pc:chgData name="Mitchell Wand" userId="de9b44c55c049659" providerId="LiveId" clId="{EA4C50BF-E095-43E6-81D2-CD7A37F76019}" dt="2022-08-30T19:41:13.191" v="1744" actId="20577"/>
-        <pc:sldMkLst>
-          <pc:docMk/>
-          <pc:sldMk cId="3759591623" sldId="364"/>
-        </pc:sldMkLst>
-        <pc:spChg chg="mod">
-          <ac:chgData name="Mitchell Wand" userId="de9b44c55c049659" providerId="LiveId" clId="{EA4C50BF-E095-43E6-81D2-CD7A37F76019}" dt="2022-08-30T19:41:13.191" v="1744" actId="20577"/>
-          <ac:spMkLst>
-            <pc:docMk/>
-            <pc:sldMk cId="3759591623" sldId="364"/>
-            <ac:spMk id="2" creationId="{05F72AF3-1C1C-4313-978C-8444DAC29385}"/>
-          </ac:spMkLst>
-        </pc:spChg>
-      </pc:sldChg>
-      <pc:sldChg chg="modSp mod">
-        <pc:chgData name="Mitchell Wand" userId="de9b44c55c049659" providerId="LiveId" clId="{EA4C50BF-E095-43E6-81D2-CD7A37F76019}" dt="2022-08-30T19:41:23.708" v="1746" actId="20577"/>
-        <pc:sldMkLst>
-          <pc:docMk/>
-          <pc:sldMk cId="3947735393" sldId="365"/>
-        </pc:sldMkLst>
-        <pc:spChg chg="mod">
-          <ac:chgData name="Mitchell Wand" userId="de9b44c55c049659" providerId="LiveId" clId="{EA4C50BF-E095-43E6-81D2-CD7A37F76019}" dt="2022-08-30T19:41:23.708" v="1746" actId="20577"/>
-          <ac:spMkLst>
-            <pc:docMk/>
-            <pc:sldMk cId="3947735393" sldId="365"/>
-            <ac:spMk id="2" creationId="{2C9E944F-BA6C-40FA-83A7-E0128B217071}"/>
-          </ac:spMkLst>
-        </pc:spChg>
-      </pc:sldChg>
-      <pc:sldChg chg="modSp mod">
-        <pc:chgData name="Mitchell Wand" userId="de9b44c55c049659" providerId="LiveId" clId="{EA4C50BF-E095-43E6-81D2-CD7A37F76019}" dt="2022-08-30T19:39:37.337" v="1741" actId="20577"/>
-        <pc:sldMkLst>
-          <pc:docMk/>
-          <pc:sldMk cId="3716223663" sldId="366"/>
-        </pc:sldMkLst>
-        <pc:spChg chg="mod">
-          <ac:chgData name="Mitchell Wand" userId="de9b44c55c049659" providerId="LiveId" clId="{EA4C50BF-E095-43E6-81D2-CD7A37F76019}" dt="2022-08-30T19:39:37.337" v="1741" actId="20577"/>
-          <ac:spMkLst>
-            <pc:docMk/>
-            <pc:sldMk cId="3716223663" sldId="366"/>
-            <ac:spMk id="3" creationId="{FCCE4D6C-6E60-4E4C-BE55-5674B33BAD01}"/>
-          </ac:spMkLst>
-        </pc:spChg>
-      </pc:sldChg>
-      <pc:sldChg chg="modNotesTx">
-        <pc:chgData name="Mitchell Wand" userId="de9b44c55c049659" providerId="LiveId" clId="{EA4C50BF-E095-43E6-81D2-CD7A37F76019}" dt="2022-08-30T20:36:56.711" v="1877" actId="20577"/>
-        <pc:sldMkLst>
-          <pc:docMk/>
-          <pc:sldMk cId="2468871028" sldId="370"/>
-        </pc:sldMkLst>
-      </pc:sldChg>
-      <pc:sldChg chg="modSp mod modNotesTx">
-        <pc:chgData name="Mitchell Wand" userId="de9b44c55c049659" providerId="LiveId" clId="{EA4C50BF-E095-43E6-81D2-CD7A37F76019}" dt="2022-08-30T19:41:32.318" v="1761" actId="20577"/>
-        <pc:sldMkLst>
-          <pc:docMk/>
-          <pc:sldMk cId="1321566400" sldId="377"/>
-        </pc:sldMkLst>
-        <pc:spChg chg="mod">
-          <ac:chgData name="Mitchell Wand" userId="de9b44c55c049659" providerId="LiveId" clId="{EA4C50BF-E095-43E6-81D2-CD7A37F76019}" dt="2022-08-30T19:41:32.318" v="1761" actId="20577"/>
-          <ac:spMkLst>
-            <pc:docMk/>
-            <pc:sldMk cId="1321566400" sldId="377"/>
-            <ac:spMk id="2" creationId="{3323B94F-DD6B-4DB4-8395-2AB67EF792C3}"/>
-          </ac:spMkLst>
-        </pc:spChg>
-      </pc:sldChg>
-      <pc:sldChg chg="modSp mod">
-        <pc:chgData name="Mitchell Wand" userId="de9b44c55c049659" providerId="LiveId" clId="{EA4C50BF-E095-43E6-81D2-CD7A37F76019}" dt="2022-08-30T18:55:39.871" v="0" actId="20577"/>
-        <pc:sldMkLst>
-          <pc:docMk/>
-          <pc:sldMk cId="2452429264" sldId="379"/>
-        </pc:sldMkLst>
-        <pc:spChg chg="mod">
-          <ac:chgData name="Mitchell Wand" userId="de9b44c55c049659" providerId="LiveId" clId="{EA4C50BF-E095-43E6-81D2-CD7A37F76019}" dt="2022-08-30T18:55:39.871" v="0" actId="20577"/>
-          <ac:spMkLst>
-            <pc:docMk/>
-            <pc:sldMk cId="2452429264" sldId="379"/>
-            <ac:spMk id="8" creationId="{5B356C44-32EB-4AC4-94B7-A86895491E70}"/>
-          </ac:spMkLst>
-        </pc:spChg>
-      </pc:sldChg>
-      <pc:sldChg chg="addSp delSp modSp new mod ord modAnim">
-        <pc:chgData name="Mitchell Wand" userId="de9b44c55c049659" providerId="LiveId" clId="{EA4C50BF-E095-43E6-81D2-CD7A37F76019}" dt="2022-08-30T19:01:26.485" v="179"/>
-        <pc:sldMkLst>
-          <pc:docMk/>
-          <pc:sldMk cId="1278534813" sldId="380"/>
-        </pc:sldMkLst>
-        <pc:spChg chg="mod">
-          <ac:chgData name="Mitchell Wand" userId="de9b44c55c049659" providerId="LiveId" clId="{EA4C50BF-E095-43E6-81D2-CD7A37F76019}" dt="2022-08-30T18:59:43.704" v="163" actId="20577"/>
-          <ac:spMkLst>
-            <pc:docMk/>
-            <pc:sldMk cId="1278534813" sldId="380"/>
-            <ac:spMk id="2" creationId="{1D34A770-8D81-BFD1-9195-638C66F46B9A}"/>
-          </ac:spMkLst>
-        </pc:spChg>
-        <pc:spChg chg="mod">
-          <ac:chgData name="Mitchell Wand" userId="de9b44c55c049659" providerId="LiveId" clId="{EA4C50BF-E095-43E6-81D2-CD7A37F76019}" dt="2022-08-30T19:00:37.467" v="174" actId="6549"/>
-          <ac:spMkLst>
-            <pc:docMk/>
-            <pc:sldMk cId="1278534813" sldId="380"/>
-            <ac:spMk id="3" creationId="{20AA8411-AAE1-73CF-7E57-9F071571944D}"/>
-          </ac:spMkLst>
-        </pc:spChg>
-        <pc:spChg chg="add del">
-          <ac:chgData name="Mitchell Wand" userId="de9b44c55c049659" providerId="LiveId" clId="{EA4C50BF-E095-43E6-81D2-CD7A37F76019}" dt="2022-08-30T19:00:50.896" v="176" actId="22"/>
-          <ac:spMkLst>
-            <pc:docMk/>
-            <pc:sldMk cId="1278534813" sldId="380"/>
-            <ac:spMk id="6" creationId="{FEAC7180-2C2E-89D8-4909-8C8FDBD79FE2}"/>
-          </ac:spMkLst>
-        </pc:spChg>
-        <pc:spChg chg="add mod">
-          <ac:chgData name="Mitchell Wand" userId="de9b44c55c049659" providerId="LiveId" clId="{EA4C50BF-E095-43E6-81D2-CD7A37F76019}" dt="2022-08-30T19:00:56.732" v="177"/>
-          <ac:spMkLst>
-            <pc:docMk/>
-            <pc:sldMk cId="1278534813" sldId="380"/>
-            <ac:spMk id="7" creationId="{8BBDEB92-85BE-2CDB-073B-4C6104E3F4D5}"/>
-          </ac:spMkLst>
-        </pc:spChg>
-      </pc:sldChg>
-      <pc:sldChg chg="addSp delSp modSp new mod">
-        <pc:chgData name="Mitchell Wand" userId="de9b44c55c049659" providerId="LiveId" clId="{EA4C50BF-E095-43E6-81D2-CD7A37F76019}" dt="2022-08-30T19:04:38.822" v="413" actId="20577"/>
-        <pc:sldMkLst>
-          <pc:docMk/>
-          <pc:sldMk cId="4257474872" sldId="381"/>
-        </pc:sldMkLst>
-        <pc:spChg chg="mod">
-          <ac:chgData name="Mitchell Wand" userId="de9b44c55c049659" providerId="LiveId" clId="{EA4C50BF-E095-43E6-81D2-CD7A37F76019}" dt="2022-08-30T19:02:32.496" v="246" actId="20577"/>
-          <ac:spMkLst>
-            <pc:docMk/>
-            <pc:sldMk cId="4257474872" sldId="381"/>
-            <ac:spMk id="2" creationId="{7C39E728-8086-5E41-2C19-BA499160C39E}"/>
-          </ac:spMkLst>
-        </pc:spChg>
-        <pc:spChg chg="del mod">
-          <ac:chgData name="Mitchell Wand" userId="de9b44c55c049659" providerId="LiveId" clId="{EA4C50BF-E095-43E6-81D2-CD7A37F76019}" dt="2022-08-30T19:03:06.666" v="271" actId="478"/>
-          <ac:spMkLst>
-            <pc:docMk/>
-            <pc:sldMk cId="4257474872" sldId="381"/>
-            <ac:spMk id="3" creationId="{DF395F07-A177-C4AF-198B-1208CBC0DE85}"/>
-          </ac:spMkLst>
-        </pc:spChg>
-        <pc:spChg chg="add mod">
-          <ac:chgData name="Mitchell Wand" userId="de9b44c55c049659" providerId="LiveId" clId="{EA4C50BF-E095-43E6-81D2-CD7A37F76019}" dt="2022-08-30T19:03:06.666" v="271" actId="478"/>
-          <ac:spMkLst>
-            <pc:docMk/>
-            <pc:sldMk cId="4257474872" sldId="381"/>
-            <ac:spMk id="6" creationId="{38BED14B-19EF-CD09-B664-7A0B10E2C042}"/>
-          </ac:spMkLst>
-        </pc:spChg>
-        <pc:spChg chg="add mod">
-          <ac:chgData name="Mitchell Wand" userId="de9b44c55c049659" providerId="LiveId" clId="{EA4C50BF-E095-43E6-81D2-CD7A37F76019}" dt="2022-08-30T19:03:19.869" v="273"/>
-          <ac:spMkLst>
-            <pc:docMk/>
-            <pc:sldMk cId="4257474872" sldId="381"/>
-            <ac:spMk id="8" creationId="{31107A69-2D8E-1214-E6CE-8CFD27A1B19D}"/>
-          </ac:spMkLst>
-        </pc:spChg>
-        <pc:spChg chg="add mod">
-          <ac:chgData name="Mitchell Wand" userId="de9b44c55c049659" providerId="LiveId" clId="{EA4C50BF-E095-43E6-81D2-CD7A37F76019}" dt="2022-08-30T19:03:19.869" v="273"/>
-          <ac:spMkLst>
-            <pc:docMk/>
-            <pc:sldMk cId="4257474872" sldId="381"/>
-            <ac:spMk id="9" creationId="{2FF3C98D-A621-FEA6-1E6A-19BEEA58AAC9}"/>
-          </ac:spMkLst>
-        </pc:spChg>
-        <pc:grpChg chg="add mod">
-          <ac:chgData name="Mitchell Wand" userId="de9b44c55c049659" providerId="LiveId" clId="{EA4C50BF-E095-43E6-81D2-CD7A37F76019}" dt="2022-08-30T19:03:19.869" v="273"/>
-          <ac:grpSpMkLst>
-            <pc:docMk/>
-            <pc:sldMk cId="4257474872" sldId="381"/>
-            <ac:grpSpMk id="7" creationId="{9F50B656-B524-F041-2528-09833E5B694F}"/>
-          </ac:grpSpMkLst>
-        </pc:grpChg>
-        <pc:graphicFrameChg chg="add mod">
-          <ac:chgData name="Mitchell Wand" userId="de9b44c55c049659" providerId="LiveId" clId="{EA4C50BF-E095-43E6-81D2-CD7A37F76019}" dt="2022-08-30T19:04:38.822" v="413" actId="20577"/>
-          <ac:graphicFrameMkLst>
-            <pc:docMk/>
-            <pc:sldMk cId="4257474872" sldId="381"/>
-            <ac:graphicFrameMk id="10" creationId="{BD762AA2-B8E6-CE63-C277-9D78BC5B5A1B}"/>
-          </ac:graphicFrameMkLst>
-        </pc:graphicFrameChg>
-      </pc:sldChg>
-      <pc:sldChg chg="addSp delSp modSp add del mod">
-        <pc:chgData name="Mitchell Wand" userId="de9b44c55c049659" providerId="LiveId" clId="{EA4C50BF-E095-43E6-81D2-CD7A37F76019}" dt="2022-08-30T19:37:27.492" v="1701" actId="2696"/>
-        <pc:sldMkLst>
-          <pc:docMk/>
-          <pc:sldMk cId="3681161191" sldId="412"/>
-        </pc:sldMkLst>
-        <pc:spChg chg="mod">
-          <ac:chgData name="Mitchell Wand" userId="de9b44c55c049659" providerId="LiveId" clId="{EA4C50BF-E095-43E6-81D2-CD7A37F76019}" dt="2022-08-30T19:06:58.711" v="458" actId="20577"/>
-          <ac:spMkLst>
-            <pc:docMk/>
-            <pc:sldMk cId="3681161191" sldId="412"/>
-            <ac:spMk id="2" creationId="{7E904B5E-91AC-4C1E-A6BE-56F6BD35DC84}"/>
-          </ac:spMkLst>
-        </pc:spChg>
-        <pc:spChg chg="del">
-          <ac:chgData name="Mitchell Wand" userId="de9b44c55c049659" providerId="LiveId" clId="{EA4C50BF-E095-43E6-81D2-CD7A37F76019}" dt="2022-08-30T19:07:04.058" v="459" actId="478"/>
-          <ac:spMkLst>
-            <pc:docMk/>
-            <pc:sldMk cId="3681161191" sldId="412"/>
-            <ac:spMk id="3" creationId="{43DDDCE9-8CC6-4685-885B-8EB6634AA878}"/>
-          </ac:spMkLst>
-        </pc:spChg>
-        <pc:spChg chg="add mod">
-          <ac:chgData name="Mitchell Wand" userId="de9b44c55c049659" providerId="LiveId" clId="{EA4C50BF-E095-43E6-81D2-CD7A37F76019}" dt="2022-08-30T19:31:53.646" v="1303" actId="20577"/>
-          <ac:spMkLst>
-            <pc:docMk/>
-            <pc:sldMk cId="3681161191" sldId="412"/>
-            <ac:spMk id="6" creationId="{63547E67-8F96-A7D4-F71E-8E4634BE8F16}"/>
-          </ac:spMkLst>
-        </pc:spChg>
-      </pc:sldChg>
-      <pc:sldChg chg="add">
-        <pc:chgData name="Mitchell Wand" userId="de9b44c55c049659" providerId="LiveId" clId="{EA4C50BF-E095-43E6-81D2-CD7A37F76019}" dt="2022-08-30T19:37:35.496" v="1702"/>
-        <pc:sldMkLst>
-          <pc:docMk/>
-          <pc:sldMk cId="3874025181" sldId="412"/>
-        </pc:sldMkLst>
-      </pc:sldChg>
-      <pc:sldChg chg="addSp delSp modSp add del mod">
-        <pc:chgData name="Mitchell Wand" userId="de9b44c55c049659" providerId="LiveId" clId="{EA4C50BF-E095-43E6-81D2-CD7A37F76019}" dt="2022-08-30T19:37:27.492" v="1701" actId="2696"/>
-        <pc:sldMkLst>
-          <pc:docMk/>
-          <pc:sldMk cId="3118770509" sldId="416"/>
-        </pc:sldMkLst>
-        <pc:spChg chg="mod">
-          <ac:chgData name="Mitchell Wand" userId="de9b44c55c049659" providerId="LiveId" clId="{EA4C50BF-E095-43E6-81D2-CD7A37F76019}" dt="2022-08-30T19:11:47.267" v="839" actId="20577"/>
-          <ac:spMkLst>
-            <pc:docMk/>
-            <pc:sldMk cId="3118770509" sldId="416"/>
-            <ac:spMk id="2" creationId="{AE3E72A7-92DE-423B-A904-AE88EDE1F8AE}"/>
-          </ac:spMkLst>
-        </pc:spChg>
-        <pc:spChg chg="mod">
-          <ac:chgData name="Mitchell Wand" userId="de9b44c55c049659" providerId="LiveId" clId="{EA4C50BF-E095-43E6-81D2-CD7A37F76019}" dt="2022-08-30T19:14:25.466" v="938" actId="27636"/>
-          <ac:spMkLst>
-            <pc:docMk/>
-            <pc:sldMk cId="3118770509" sldId="416"/>
-            <ac:spMk id="3" creationId="{F5A32929-7727-49E3-92D6-0FD395A65342}"/>
-          </ac:spMkLst>
-        </pc:spChg>
-        <pc:spChg chg="add mod">
-          <ac:chgData name="Mitchell Wand" userId="de9b44c55c049659" providerId="LiveId" clId="{EA4C50BF-E095-43E6-81D2-CD7A37F76019}" dt="2022-08-30T19:13:34.553" v="916" actId="207"/>
-          <ac:spMkLst>
-            <pc:docMk/>
-            <pc:sldMk cId="3118770509" sldId="416"/>
-            <ac:spMk id="5" creationId="{842EFB36-9979-DF75-FA0B-A84EA0690AD6}"/>
-          </ac:spMkLst>
-        </pc:spChg>
-        <pc:spChg chg="add mod">
-          <ac:chgData name="Mitchell Wand" userId="de9b44c55c049659" providerId="LiveId" clId="{EA4C50BF-E095-43E6-81D2-CD7A37F76019}" dt="2022-08-30T19:15:37.602" v="1066" actId="255"/>
-          <ac:spMkLst>
-            <pc:docMk/>
-            <pc:sldMk cId="3118770509" sldId="416"/>
-            <ac:spMk id="6" creationId="{C479E27F-A6F8-875E-7954-4BE8EDE3B7D1}"/>
-          </ac:spMkLst>
-        </pc:spChg>
-        <pc:spChg chg="add del mod">
-          <ac:chgData name="Mitchell Wand" userId="de9b44c55c049659" providerId="LiveId" clId="{EA4C50BF-E095-43E6-81D2-CD7A37F76019}" dt="2022-08-30T19:15:25.884" v="1065" actId="478"/>
-          <ac:spMkLst>
-            <pc:docMk/>
-            <pc:sldMk cId="3118770509" sldId="416"/>
-            <ac:spMk id="7" creationId="{B7DCD927-1740-C0B7-46B7-689CF9FBB05F}"/>
-          </ac:spMkLst>
-        </pc:spChg>
-        <pc:spChg chg="add mod">
-          <ac:chgData name="Mitchell Wand" userId="de9b44c55c049659" providerId="LiveId" clId="{EA4C50BF-E095-43E6-81D2-CD7A37F76019}" dt="2022-08-30T19:16:23.818" v="1081" actId="1076"/>
-          <ac:spMkLst>
-            <pc:docMk/>
-            <pc:sldMk cId="3118770509" sldId="416"/>
-            <ac:spMk id="8" creationId="{198A1E92-4E24-D593-0C9F-41878B075BA1}"/>
-          </ac:spMkLst>
-        </pc:spChg>
-        <pc:spChg chg="add del mod">
-          <ac:chgData name="Mitchell Wand" userId="de9b44c55c049659" providerId="LiveId" clId="{EA4C50BF-E095-43E6-81D2-CD7A37F76019}" dt="2022-08-30T19:16:13.655" v="1079" actId="478"/>
-          <ac:spMkLst>
-            <pc:docMk/>
-            <pc:sldMk cId="3118770509" sldId="416"/>
-            <ac:spMk id="9" creationId="{79B798F3-4DD2-47C0-B361-AE3FFD5C8276}"/>
-          </ac:spMkLst>
-        </pc:spChg>
-        <pc:spChg chg="add mod">
-          <ac:chgData name="Mitchell Wand" userId="de9b44c55c049659" providerId="LiveId" clId="{EA4C50BF-E095-43E6-81D2-CD7A37F76019}" dt="2022-08-30T19:16:38.567" v="1090" actId="20577"/>
-          <ac:spMkLst>
-            <pc:docMk/>
-            <pc:sldMk cId="3118770509" sldId="416"/>
-            <ac:spMk id="10" creationId="{0415E4AA-28FD-834C-5DE8-954BF316814F}"/>
-          </ac:spMkLst>
-        </pc:spChg>
-      </pc:sldChg>
-      <pc:sldChg chg="add">
-        <pc:chgData name="Mitchell Wand" userId="de9b44c55c049659" providerId="LiveId" clId="{EA4C50BF-E095-43E6-81D2-CD7A37F76019}" dt="2022-08-30T19:37:35.496" v="1702"/>
-        <pc:sldMkLst>
-          <pc:docMk/>
-          <pc:sldMk cId="4285151892" sldId="416"/>
-        </pc:sldMkLst>
-      </pc:sldChg>
-      <pc:sldChg chg="add del">
-        <pc:chgData name="Mitchell Wand" userId="de9b44c55c049659" providerId="LiveId" clId="{EA4C50BF-E095-43E6-81D2-CD7A37F76019}" dt="2022-08-30T19:37:27.492" v="1701" actId="2696"/>
-        <pc:sldMkLst>
-          <pc:docMk/>
-          <pc:sldMk cId="207312408" sldId="417"/>
-        </pc:sldMkLst>
-      </pc:sldChg>
-      <pc:sldChg chg="add">
-        <pc:chgData name="Mitchell Wand" userId="de9b44c55c049659" providerId="LiveId" clId="{EA4C50BF-E095-43E6-81D2-CD7A37F76019}" dt="2022-08-30T19:37:35.496" v="1702"/>
-        <pc:sldMkLst>
-          <pc:docMk/>
-          <pc:sldMk cId="250917390" sldId="417"/>
-        </pc:sldMkLst>
-      </pc:sldChg>
-      <pc:sldChg chg="modSp add del mod ord">
-        <pc:chgData name="Mitchell Wand" userId="de9b44c55c049659" providerId="LiveId" clId="{EA4C50BF-E095-43E6-81D2-CD7A37F76019}" dt="2022-08-30T19:37:27.492" v="1701" actId="2696"/>
-        <pc:sldMkLst>
-          <pc:docMk/>
-          <pc:sldMk cId="128826574" sldId="418"/>
-        </pc:sldMkLst>
-        <pc:spChg chg="mod">
-          <ac:chgData name="Mitchell Wand" userId="de9b44c55c049659" providerId="LiveId" clId="{EA4C50BF-E095-43E6-81D2-CD7A37F76019}" dt="2022-08-30T19:12:09.841" v="852" actId="20577"/>
-          <ac:spMkLst>
-            <pc:docMk/>
-            <pc:sldMk cId="128826574" sldId="418"/>
-            <ac:spMk id="2" creationId="{8A0F2821-41CE-4E1B-9203-CE081F2CFC59}"/>
-          </ac:spMkLst>
-        </pc:spChg>
-      </pc:sldChg>
-      <pc:sldChg chg="add">
-        <pc:chgData name="Mitchell Wand" userId="de9b44c55c049659" providerId="LiveId" clId="{EA4C50BF-E095-43E6-81D2-CD7A37F76019}" dt="2022-08-30T19:37:35.496" v="1702"/>
-        <pc:sldMkLst>
-          <pc:docMk/>
-          <pc:sldMk cId="3578469217" sldId="418"/>
-        </pc:sldMkLst>
-      </pc:sldChg>
-      <pc:sldChg chg="add del">
-        <pc:chgData name="Mitchell Wand" userId="de9b44c55c049659" providerId="LiveId" clId="{EA4C50BF-E095-43E6-81D2-CD7A37F76019}" dt="2022-08-30T19:16:52.483" v="1091" actId="2696"/>
-        <pc:sldMkLst>
-          <pc:docMk/>
-          <pc:sldMk cId="2242979527" sldId="419"/>
-        </pc:sldMkLst>
-      </pc:sldChg>
-      <pc:sldChg chg="add del">
-        <pc:chgData name="Mitchell Wand" userId="de9b44c55c049659" providerId="LiveId" clId="{EA4C50BF-E095-43E6-81D2-CD7A37F76019}" dt="2022-08-30T19:32:38.853" v="1305" actId="2696"/>
-        <pc:sldMkLst>
-          <pc:docMk/>
-          <pc:sldMk cId="1716946712" sldId="420"/>
-        </pc:sldMkLst>
-      </pc:sldChg>
-      <pc:sldChg chg="add del">
-        <pc:chgData name="Mitchell Wand" userId="de9b44c55c049659" providerId="LiveId" clId="{EA4C50BF-E095-43E6-81D2-CD7A37F76019}" dt="2022-08-30T19:32:43.090" v="1306" actId="2696"/>
-        <pc:sldMkLst>
-          <pc:docMk/>
-          <pc:sldMk cId="3290665104" sldId="421"/>
-        </pc:sldMkLst>
-      </pc:sldChg>
-      <pc:sldChg chg="add del">
-        <pc:chgData name="Mitchell Wand" userId="de9b44c55c049659" providerId="LiveId" clId="{EA4C50BF-E095-43E6-81D2-CD7A37F76019}" dt="2022-08-30T19:33:01.363" v="1308" actId="2696"/>
-        <pc:sldMkLst>
-          <pc:docMk/>
-          <pc:sldMk cId="125374142" sldId="422"/>
-        </pc:sldMkLst>
-      </pc:sldChg>
-      <pc:sldChg chg="add del ord">
-        <pc:chgData name="Mitchell Wand" userId="de9b44c55c049659" providerId="LiveId" clId="{EA4C50BF-E095-43E6-81D2-CD7A37F76019}" dt="2022-08-30T19:32:05.452" v="1304" actId="2696"/>
-        <pc:sldMkLst>
-          <pc:docMk/>
-          <pc:sldMk cId="3711311485" sldId="424"/>
-        </pc:sldMkLst>
-      </pc:sldChg>
-      <pc:sldChg chg="modSp add del mod">
-        <pc:chgData name="Mitchell Wand" userId="de9b44c55c049659" providerId="LiveId" clId="{EA4C50BF-E095-43E6-81D2-CD7A37F76019}" dt="2022-08-30T19:37:27.492" v="1701" actId="2696"/>
-        <pc:sldMkLst>
-          <pc:docMk/>
-          <pc:sldMk cId="2964924213" sldId="430"/>
-        </pc:sldMkLst>
-        <pc:spChg chg="mod">
-          <ac:chgData name="Mitchell Wand" userId="de9b44c55c049659" providerId="LiveId" clId="{EA4C50BF-E095-43E6-81D2-CD7A37F76019}" dt="2022-08-30T19:07:21.301" v="470" actId="20577"/>
-          <ac:spMkLst>
-            <pc:docMk/>
-            <pc:sldMk cId="2964924213" sldId="430"/>
-            <ac:spMk id="2" creationId="{DD46A4C1-A4E1-4FD4-B266-9FFE28C51D1D}"/>
-          </ac:spMkLst>
-        </pc:spChg>
-        <pc:spChg chg="mod">
-          <ac:chgData name="Mitchell Wand" userId="de9b44c55c049659" providerId="LiveId" clId="{EA4C50BF-E095-43E6-81D2-CD7A37F76019}" dt="2022-08-30T19:11:06.935" v="828" actId="6549"/>
-          <ac:spMkLst>
-            <pc:docMk/>
-            <pc:sldMk cId="2964924213" sldId="430"/>
-            <ac:spMk id="3" creationId="{A83ACF0D-4A17-4131-90E7-C5D2C0B64C01}"/>
-          </ac:spMkLst>
-        </pc:spChg>
-      </pc:sldChg>
-      <pc:sldChg chg="add">
-        <pc:chgData name="Mitchell Wand" userId="de9b44c55c049659" providerId="LiveId" clId="{EA4C50BF-E095-43E6-81D2-CD7A37F76019}" dt="2022-08-30T19:37:35.496" v="1702"/>
-        <pc:sldMkLst>
-          <pc:docMk/>
-          <pc:sldMk cId="3345968335" sldId="430"/>
-        </pc:sldMkLst>
-      </pc:sldChg>
-      <pc:sldChg chg="add del">
-        <pc:chgData name="Mitchell Wand" userId="de9b44c55c049659" providerId="LiveId" clId="{EA4C50BF-E095-43E6-81D2-CD7A37F76019}" dt="2022-08-30T19:32:48.443" v="1307" actId="2696"/>
-        <pc:sldMkLst>
-          <pc:docMk/>
-          <pc:sldMk cId="414894705" sldId="487"/>
-        </pc:sldMkLst>
-      </pc:sldChg>
-      <pc:sldChg chg="add del">
-        <pc:chgData name="Mitchell Wand" userId="de9b44c55c049659" providerId="LiveId" clId="{EA4C50BF-E095-43E6-81D2-CD7A37F76019}" dt="2022-08-30T19:33:05.290" v="1309" actId="2696"/>
-        <pc:sldMkLst>
-          <pc:docMk/>
-          <pc:sldMk cId="3513977778" sldId="488"/>
-        </pc:sldMkLst>
-      </pc:sldChg>
-      <pc:sldChg chg="addSp delSp modSp add del mod">
-        <pc:chgData name="Mitchell Wand" userId="de9b44c55c049659" providerId="LiveId" clId="{EA4C50BF-E095-43E6-81D2-CD7A37F76019}" dt="2022-08-30T19:31:28.845" v="1266" actId="2696"/>
-        <pc:sldMkLst>
-          <pc:docMk/>
-          <pc:sldMk cId="199340302" sldId="489"/>
-        </pc:sldMkLst>
-        <pc:spChg chg="mod">
-          <ac:chgData name="Mitchell Wand" userId="de9b44c55c049659" providerId="LiveId" clId="{EA4C50BF-E095-43E6-81D2-CD7A37F76019}" dt="2022-08-30T19:18:46.267" v="1146" actId="20577"/>
-          <ac:spMkLst>
-            <pc:docMk/>
-            <pc:sldMk cId="199340302" sldId="489"/>
-            <ac:spMk id="2" creationId="{8A0F2821-41CE-4E1B-9203-CE081F2CFC59}"/>
-          </ac:spMkLst>
-        </pc:spChg>
-        <pc:spChg chg="mod">
-          <ac:chgData name="Mitchell Wand" userId="de9b44c55c049659" providerId="LiveId" clId="{EA4C50BF-E095-43E6-81D2-CD7A37F76019}" dt="2022-08-30T19:19:16.391" v="1200" actId="20577"/>
-          <ac:spMkLst>
-            <pc:docMk/>
-            <pc:sldMk cId="199340302" sldId="489"/>
-            <ac:spMk id="3" creationId="{C6231731-3D93-423B-8492-07065E7282D5}"/>
-          </ac:spMkLst>
-        </pc:spChg>
-        <pc:picChg chg="del">
-          <ac:chgData name="Mitchell Wand" userId="de9b44c55c049659" providerId="LiveId" clId="{EA4C50BF-E095-43E6-81D2-CD7A37F76019}" dt="2022-08-30T19:18:58.104" v="1147" actId="478"/>
-          <ac:picMkLst>
-            <pc:docMk/>
-            <pc:sldMk cId="199340302" sldId="489"/>
-            <ac:picMk id="6" creationId="{3F997C1C-C659-436B-B706-100851C99115}"/>
-          </ac:picMkLst>
-        </pc:picChg>
-        <pc:picChg chg="del mod">
-          <ac:chgData name="Mitchell Wand" userId="de9b44c55c049659" providerId="LiveId" clId="{EA4C50BF-E095-43E6-81D2-CD7A37F76019}" dt="2022-08-30T19:24:30.383" v="1209" actId="21"/>
-          <ac:picMkLst>
-            <pc:docMk/>
-            <pc:sldMk cId="199340302" sldId="489"/>
-            <ac:picMk id="8" creationId="{789D6D95-D37A-41A3-9DE5-E6CAFBEF0F1D}"/>
-          </ac:picMkLst>
-        </pc:picChg>
-        <pc:picChg chg="add mod">
-          <ac:chgData name="Mitchell Wand" userId="de9b44c55c049659" providerId="LiveId" clId="{EA4C50BF-E095-43E6-81D2-CD7A37F76019}" dt="2022-08-30T19:24:39.153" v="1210" actId="1076"/>
-          <ac:picMkLst>
-            <pc:docMk/>
-            <pc:sldMk cId="199340302" sldId="489"/>
-            <ac:picMk id="1026" creationId="{2E551191-41EE-C7D0-E3B5-DE7856ABCEE5}"/>
-          </ac:picMkLst>
-        </pc:picChg>
-      </pc:sldChg>
-      <pc:sldChg chg="add">
-        <pc:chgData name="Mitchell Wand" userId="de9b44c55c049659" providerId="LiveId" clId="{EA4C50BF-E095-43E6-81D2-CD7A37F76019}" dt="2022-08-30T19:37:35.496" v="1702"/>
-        <pc:sldMkLst>
-          <pc:docMk/>
-          <pc:sldMk cId="81920931" sldId="490"/>
-        </pc:sldMkLst>
-      </pc:sldChg>
-      <pc:sldChg chg="addSp delSp modSp add del mod">
-        <pc:chgData name="Mitchell Wand" userId="de9b44c55c049659" providerId="LiveId" clId="{EA4C50BF-E095-43E6-81D2-CD7A37F76019}" dt="2022-08-30T19:37:27.492" v="1701" actId="2696"/>
-        <pc:sldMkLst>
-          <pc:docMk/>
-          <pc:sldMk cId="2410754075" sldId="490"/>
-        </pc:sldMkLst>
-        <pc:spChg chg="mod">
-          <ac:chgData name="Mitchell Wand" userId="de9b44c55c049659" providerId="LiveId" clId="{EA4C50BF-E095-43E6-81D2-CD7A37F76019}" dt="2022-08-30T19:28:16.553" v="1239" actId="20577"/>
-          <ac:spMkLst>
-            <pc:docMk/>
-            <pc:sldMk cId="2410754075" sldId="490"/>
-            <ac:spMk id="3" creationId="{C6231731-3D93-423B-8492-07065E7282D5}"/>
-          </ac:spMkLst>
-        </pc:spChg>
-        <pc:spChg chg="add mod">
-          <ac:chgData name="Mitchell Wand" userId="de9b44c55c049659" providerId="LiveId" clId="{EA4C50BF-E095-43E6-81D2-CD7A37F76019}" dt="2022-08-30T19:28:03.019" v="1229" actId="208"/>
-          <ac:spMkLst>
-            <pc:docMk/>
-            <pc:sldMk cId="2410754075" sldId="490"/>
-            <ac:spMk id="6" creationId="{6E4DB1F4-2510-A020-2881-1E612BB14DDC}"/>
-          </ac:spMkLst>
-        </pc:spChg>
-        <pc:picChg chg="add mod">
-          <ac:chgData name="Mitchell Wand" userId="de9b44c55c049659" providerId="LiveId" clId="{EA4C50BF-E095-43E6-81D2-CD7A37F76019}" dt="2022-08-30T19:26:22.407" v="1214" actId="1076"/>
-          <ac:picMkLst>
-            <pc:docMk/>
-            <pc:sldMk cId="2410754075" sldId="490"/>
-            <ac:picMk id="5" creationId="{69045311-9FBA-5A4D-ADD9-613CD6EE4B08}"/>
-          </ac:picMkLst>
-        </pc:picChg>
-        <pc:picChg chg="del">
-          <ac:chgData name="Mitchell Wand" userId="de9b44c55c049659" providerId="LiveId" clId="{EA4C50BF-E095-43E6-81D2-CD7A37F76019}" dt="2022-08-30T19:26:02.436" v="1212" actId="478"/>
-          <ac:picMkLst>
-            <pc:docMk/>
-            <pc:sldMk cId="2410754075" sldId="490"/>
-            <ac:picMk id="1026" creationId="{2E551191-41EE-C7D0-E3B5-DE7856ABCEE5}"/>
-          </ac:picMkLst>
-        </pc:picChg>
-        <pc:cxnChg chg="add mod">
-          <ac:chgData name="Mitchell Wand" userId="de9b44c55c049659" providerId="LiveId" clId="{EA4C50BF-E095-43E6-81D2-CD7A37F76019}" dt="2022-08-30T19:31:05.305" v="1265" actId="14100"/>
-          <ac:cxnSpMkLst>
-            <pc:docMk/>
-            <pc:sldMk cId="2410754075" sldId="490"/>
-            <ac:cxnSpMk id="8" creationId="{B3727DDA-7256-B719-54C2-CEF522A4484C}"/>
-          </ac:cxnSpMkLst>
-        </pc:cxnChg>
-        <pc:cxnChg chg="add mod">
-          <ac:chgData name="Mitchell Wand" userId="de9b44c55c049659" providerId="LiveId" clId="{EA4C50BF-E095-43E6-81D2-CD7A37F76019}" dt="2022-08-30T19:30:52.907" v="1261" actId="14100"/>
-          <ac:cxnSpMkLst>
-            <pc:docMk/>
-            <pc:sldMk cId="2410754075" sldId="490"/>
-            <ac:cxnSpMk id="9" creationId="{766FC09C-4EC0-055C-631E-2129B426876D}"/>
-          </ac:cxnSpMkLst>
-        </pc:cxnChg>
-        <pc:cxnChg chg="add mod">
-          <ac:chgData name="Mitchell Wand" userId="de9b44c55c049659" providerId="LiveId" clId="{EA4C50BF-E095-43E6-81D2-CD7A37F76019}" dt="2022-08-30T19:30:31.280" v="1259" actId="14100"/>
-          <ac:cxnSpMkLst>
-            <pc:docMk/>
-            <pc:sldMk cId="2410754075" sldId="490"/>
-            <ac:cxnSpMk id="10" creationId="{73C4F1DA-D1BE-4E91-89F3-53457156C5F2}"/>
-          </ac:cxnSpMkLst>
-        </pc:cxnChg>
-        <pc:cxnChg chg="add mod">
-          <ac:chgData name="Mitchell Wand" userId="de9b44c55c049659" providerId="LiveId" clId="{EA4C50BF-E095-43E6-81D2-CD7A37F76019}" dt="2022-08-30T19:30:04.282" v="1253" actId="14100"/>
-          <ac:cxnSpMkLst>
-            <pc:docMk/>
-            <pc:sldMk cId="2410754075" sldId="490"/>
-            <ac:cxnSpMk id="11" creationId="{67E39126-C07E-0DB0-EEBD-B4E5B629B7BD}"/>
-          </ac:cxnSpMkLst>
-        </pc:cxnChg>
-        <pc:cxnChg chg="add mod">
-          <ac:chgData name="Mitchell Wand" userId="de9b44c55c049659" providerId="LiveId" clId="{EA4C50BF-E095-43E6-81D2-CD7A37F76019}" dt="2022-08-30T19:29:46.661" v="1251" actId="14100"/>
-          <ac:cxnSpMkLst>
-            <pc:docMk/>
-            <pc:sldMk cId="2410754075" sldId="490"/>
-            <ac:cxnSpMk id="12" creationId="{AF193149-7CAB-37F4-44BC-5B5517E5588D}"/>
-          </ac:cxnSpMkLst>
-        </pc:cxnChg>
-      </pc:sldChg>
-      <pc:sldChg chg="add">
-        <pc:chgData name="Mitchell Wand" userId="de9b44c55c049659" providerId="LiveId" clId="{EA4C50BF-E095-43E6-81D2-CD7A37F76019}" dt="2022-08-30T19:37:35.496" v="1702"/>
-        <pc:sldMkLst>
-          <pc:docMk/>
-          <pc:sldMk cId="1802476990" sldId="491"/>
-        </pc:sldMkLst>
-      </pc:sldChg>
-      <pc:sldChg chg="modSp new del mod">
-        <pc:chgData name="Mitchell Wand" userId="de9b44c55c049659" providerId="LiveId" clId="{EA4C50BF-E095-43E6-81D2-CD7A37F76019}" dt="2022-08-30T19:37:27.492" v="1701" actId="2696"/>
-        <pc:sldMkLst>
-          <pc:docMk/>
-          <pc:sldMk cId="4248889327" sldId="491"/>
-        </pc:sldMkLst>
-        <pc:spChg chg="mod">
-          <ac:chgData name="Mitchell Wand" userId="de9b44c55c049659" providerId="LiveId" clId="{EA4C50BF-E095-43E6-81D2-CD7A37F76019}" dt="2022-08-30T19:33:43.443" v="1343" actId="20577"/>
-          <ac:spMkLst>
-            <pc:docMk/>
-            <pc:sldMk cId="4248889327" sldId="491"/>
-            <ac:spMk id="2" creationId="{815A0EE6-0625-3F43-76E9-143FD7F06B27}"/>
-          </ac:spMkLst>
-        </pc:spChg>
-        <pc:spChg chg="mod">
-          <ac:chgData name="Mitchell Wand" userId="de9b44c55c049659" providerId="LiveId" clId="{EA4C50BF-E095-43E6-81D2-CD7A37F76019}" dt="2022-08-30T19:36:16.847" v="1644" actId="20577"/>
-          <ac:spMkLst>
-            <pc:docMk/>
-            <pc:sldMk cId="4248889327" sldId="491"/>
-            <ac:spMk id="3" creationId="{0DA8F21C-0D26-599F-3A1C-78D34F165CB3}"/>
-          </ac:spMkLst>
-        </pc:spChg>
-      </pc:sldChg>
-      <pc:sldChg chg="modSp new mod">
-        <pc:chgData name="Mitchell Wand" userId="de9b44c55c049659" providerId="LiveId" clId="{EA4C50BF-E095-43E6-81D2-CD7A37F76019}" dt="2022-08-30T19:37:06.103" v="1700" actId="20577"/>
-        <pc:sldMkLst>
-          <pc:docMk/>
-          <pc:sldMk cId="509432682" sldId="492"/>
-        </pc:sldMkLst>
-        <pc:spChg chg="mod">
-          <ac:chgData name="Mitchell Wand" userId="de9b44c55c049659" providerId="LiveId" clId="{EA4C50BF-E095-43E6-81D2-CD7A37F76019}" dt="2022-08-30T19:37:06.103" v="1700" actId="20577"/>
-          <ac:spMkLst>
-            <pc:docMk/>
-            <pc:sldMk cId="509432682" sldId="492"/>
-            <ac:spMk id="2" creationId="{6D4FDDBB-CE87-8647-122B-DCC6AD94D23F}"/>
-          </ac:spMkLst>
-        </pc:spChg>
-      </pc:sldChg>
-    </pc:docChg>
-  </pc:docChgLst>
-  <pc:docChgLst>
-    <pc:chgData name="Mitchell Wand" userId="de9b44c55c049659" providerId="LiveId" clId="{F51B1847-95FF-4053-B76F-28C840121525}"/>
-    <pc:docChg chg="addSld delSld modSld">
-      <pc:chgData name="Mitchell Wand" userId="de9b44c55c049659" providerId="LiveId" clId="{F51B1847-95FF-4053-B76F-28C840121525}" dt="2024-09-03T01:47:57.061" v="1644" actId="2696"/>
-      <pc:docMkLst>
-        <pc:docMk/>
-      </pc:docMkLst>
-      <pc:sldChg chg="addSp modSp mod modAnim modNotesTx">
-        <pc:chgData name="Mitchell Wand" userId="de9b44c55c049659" providerId="LiveId" clId="{F51B1847-95FF-4053-B76F-28C840121525}" dt="2024-09-03T01:34:55.374" v="592" actId="20577"/>
-        <pc:sldMkLst>
-          <pc:docMk/>
-          <pc:sldMk cId="657427070" sldId="496"/>
-        </pc:sldMkLst>
-        <pc:spChg chg="add mod">
-          <ac:chgData name="Mitchell Wand" userId="de9b44c55c049659" providerId="LiveId" clId="{F51B1847-95FF-4053-B76F-28C840121525}" dt="2024-09-03T01:26:59.280" v="3" actId="1076"/>
-          <ac:spMkLst>
-            <pc:docMk/>
-            <pc:sldMk cId="657427070" sldId="496"/>
-            <ac:spMk id="3" creationId="{273F088B-3B9A-8204-31DE-C59AFF5D341B}"/>
-          </ac:spMkLst>
-        </pc:spChg>
-      </pc:sldChg>
-      <pc:sldChg chg="modNotesTx">
-        <pc:chgData name="Mitchell Wand" userId="de9b44c55c049659" providerId="LiveId" clId="{F51B1847-95FF-4053-B76F-28C840121525}" dt="2024-09-03T01:36:52.326" v="818" actId="20577"/>
-        <pc:sldMkLst>
-          <pc:docMk/>
-          <pc:sldMk cId="1198500969" sldId="497"/>
-        </pc:sldMkLst>
-      </pc:sldChg>
-      <pc:sldChg chg="modNotesTx">
-        <pc:chgData name="Mitchell Wand" userId="de9b44c55c049659" providerId="LiveId" clId="{F51B1847-95FF-4053-B76F-28C840121525}" dt="2024-09-03T01:40:18.139" v="1144" actId="20577"/>
-        <pc:sldMkLst>
-          <pc:docMk/>
-          <pc:sldMk cId="2839435653" sldId="498"/>
-        </pc:sldMkLst>
-      </pc:sldChg>
-      <pc:sldChg chg="modNotesTx">
-        <pc:chgData name="Mitchell Wand" userId="de9b44c55c049659" providerId="LiveId" clId="{F51B1847-95FF-4053-B76F-28C840121525}" dt="2024-09-03T01:41:10.727" v="1279" actId="20577"/>
-        <pc:sldMkLst>
-          <pc:docMk/>
-          <pc:sldMk cId="4155274164" sldId="499"/>
-        </pc:sldMkLst>
-      </pc:sldChg>
-      <pc:sldChg chg="modNotesTx">
-        <pc:chgData name="Mitchell Wand" userId="de9b44c55c049659" providerId="LiveId" clId="{F51B1847-95FF-4053-B76F-28C840121525}" dt="2024-09-03T01:43:06.941" v="1351" actId="20577"/>
-        <pc:sldMkLst>
-          <pc:docMk/>
-          <pc:sldMk cId="1442055128" sldId="502"/>
-        </pc:sldMkLst>
-      </pc:sldChg>
-      <pc:sldChg chg="mod modShow">
-        <pc:chgData name="Mitchell Wand" userId="de9b44c55c049659" providerId="LiveId" clId="{F51B1847-95FF-4053-B76F-28C840121525}" dt="2024-09-03T01:37:08.739" v="819" actId="729"/>
-        <pc:sldMkLst>
-          <pc:docMk/>
-          <pc:sldMk cId="3512688338" sldId="504"/>
-        </pc:sldMkLst>
-      </pc:sldChg>
-      <pc:sldChg chg="modNotesTx">
-        <pc:chgData name="Mitchell Wand" userId="de9b44c55c049659" providerId="LiveId" clId="{F51B1847-95FF-4053-B76F-28C840121525}" dt="2024-09-03T01:46:00.977" v="1642" actId="20577"/>
-        <pc:sldMkLst>
-          <pc:docMk/>
-          <pc:sldMk cId="935629653" sldId="506"/>
-        </pc:sldMkLst>
-      </pc:sldChg>
-      <pc:sldChg chg="add del">
-        <pc:chgData name="Mitchell Wand" userId="de9b44c55c049659" providerId="LiveId" clId="{F51B1847-95FF-4053-B76F-28C840121525}" dt="2024-09-03T01:47:57.061" v="1644" actId="2696"/>
-        <pc:sldMkLst>
-          <pc:docMk/>
-          <pc:sldMk cId="3121632177" sldId="514"/>
-        </pc:sldMkLst>
-      </pc:sldChg>
-    </pc:docChg>
-  </pc:docChgLst>
-  <pc:docChgLst>
-    <pc:chgData name="Mitchell Wand" userId="de9b44c55c049659" providerId="LiveId" clId="{99718308-7C56-473B-8B2B-53B03B1B7395}"/>
-    <pc:docChg chg="undo custSel addSld modSld">
-      <pc:chgData name="Mitchell Wand" userId="de9b44c55c049659" providerId="LiveId" clId="{99718308-7C56-473B-8B2B-53B03B1B7395}" dt="2022-09-14T18:51:01.402" v="704" actId="27636"/>
-      <pc:docMkLst>
-        <pc:docMk/>
-      </pc:docMkLst>
-      <pc:sldChg chg="addSp modSp add mod modAnim modNotesTx">
-        <pc:chgData name="Mitchell Wand" userId="de9b44c55c049659" providerId="LiveId" clId="{99718308-7C56-473B-8B2B-53B03B1B7395}" dt="2022-09-14T18:51:01.402" v="704" actId="27636"/>
-        <pc:sldMkLst>
-          <pc:docMk/>
-          <pc:sldMk cId="3605028067" sldId="495"/>
-        </pc:sldMkLst>
-        <pc:spChg chg="mod">
-          <ac:chgData name="Mitchell Wand" userId="de9b44c55c049659" providerId="LiveId" clId="{99718308-7C56-473B-8B2B-53B03B1B7395}" dt="2022-09-14T18:40:45.997" v="75" actId="20577"/>
-          <ac:spMkLst>
-            <pc:docMk/>
-            <pc:sldMk cId="3605028067" sldId="495"/>
-            <ac:spMk id="2" creationId="{BA745527-D100-4B4F-829D-1B696CAF1C9B}"/>
-          </ac:spMkLst>
-        </pc:spChg>
-        <pc:spChg chg="mod">
-          <ac:chgData name="Mitchell Wand" userId="de9b44c55c049659" providerId="LiveId" clId="{99718308-7C56-473B-8B2B-53B03B1B7395}" dt="2022-09-14T18:51:01.402" v="704" actId="27636"/>
-          <ac:spMkLst>
-            <pc:docMk/>
-            <pc:sldMk cId="3605028067" sldId="495"/>
-            <ac:spMk id="3" creationId="{FCCE4D6C-6E60-4E4C-BE55-5674B33BAD01}"/>
-          </ac:spMkLst>
-        </pc:spChg>
-        <pc:spChg chg="mod">
-          <ac:chgData name="Mitchell Wand" userId="de9b44c55c049659" providerId="LiveId" clId="{99718308-7C56-473B-8B2B-53B03B1B7395}" dt="2022-09-14T18:39:05.942" v="17" actId="255"/>
-          <ac:spMkLst>
-            <pc:docMk/>
-            <pc:sldMk cId="3605028067" sldId="495"/>
-            <ac:spMk id="5" creationId="{7A7CE241-579A-C00B-2C03-8055423915D5}"/>
-          </ac:spMkLst>
-        </pc:spChg>
-        <pc:spChg chg="mod">
-          <ac:chgData name="Mitchell Wand" userId="de9b44c55c049659" providerId="LiveId" clId="{99718308-7C56-473B-8B2B-53B03B1B7395}" dt="2022-09-14T18:39:17.321" v="20" actId="20577"/>
-          <ac:spMkLst>
-            <pc:docMk/>
-            <pc:sldMk cId="3605028067" sldId="495"/>
-            <ac:spMk id="6" creationId="{DDC06498-1D10-4E52-A107-990734307F51}"/>
-          </ac:spMkLst>
-        </pc:spChg>
-        <pc:spChg chg="add mod">
-          <ac:chgData name="Mitchell Wand" userId="de9b44c55c049659" providerId="LiveId" clId="{99718308-7C56-473B-8B2B-53B03B1B7395}" dt="2022-09-14T18:40:01.254" v="26" actId="255"/>
-          <ac:spMkLst>
-            <pc:docMk/>
-            <pc:sldMk cId="3605028067" sldId="495"/>
-            <ac:spMk id="11" creationId="{1B7168C4-C6D5-1024-A1FA-7A1C9E11C8D2}"/>
-          </ac:spMkLst>
-        </pc:spChg>
-      </pc:sldChg>
-    </pc:docChg>
-  </pc:docChgLst>
-  <pc:docChgLst>
-    <pc:chgData name="Mitchell Wand" userId="de9b44c55c049659" providerId="LiveId" clId="{1B3D1EA2-D633-4A89-BCEE-7757CCB4FD42}"/>
-    <pc:docChg chg="undo custSel modSld">
-      <pc:chgData name="Mitchell Wand" userId="de9b44c55c049659" providerId="LiveId" clId="{1B3D1EA2-D633-4A89-BCEE-7757CCB4FD42}" dt="2023-01-07T17:13:38.282" v="157" actId="20577"/>
-      <pc:docMkLst>
-        <pc:docMk/>
-      </pc:docMkLst>
-      <pc:sldChg chg="modSp mod">
-        <pc:chgData name="Mitchell Wand" userId="de9b44c55c049659" providerId="LiveId" clId="{1B3D1EA2-D633-4A89-BCEE-7757CCB4FD42}" dt="2023-01-07T17:09:49.689" v="18" actId="14100"/>
-        <pc:sldMkLst>
-          <pc:docMk/>
-          <pc:sldMk cId="915762083" sldId="361"/>
-        </pc:sldMkLst>
-        <pc:spChg chg="mod">
-          <ac:chgData name="Mitchell Wand" userId="de9b44c55c049659" providerId="LiveId" clId="{1B3D1EA2-D633-4A89-BCEE-7757CCB4FD42}" dt="2023-01-07T17:09:49.689" v="18" actId="14100"/>
-          <ac:spMkLst>
-            <pc:docMk/>
-            <pc:sldMk cId="915762083" sldId="361"/>
-            <ac:spMk id="5" creationId="{BE237715-0D80-47DC-8219-FE3B73352717}"/>
-          </ac:spMkLst>
-        </pc:spChg>
-        <pc:spChg chg="mod">
-          <ac:chgData name="Mitchell Wand" userId="de9b44c55c049659" providerId="LiveId" clId="{1B3D1EA2-D633-4A89-BCEE-7757CCB4FD42}" dt="2023-01-07T17:09:36.780" v="16"/>
-          <ac:spMkLst>
-            <pc:docMk/>
-            <pc:sldMk cId="915762083" sldId="361"/>
-            <ac:spMk id="6" creationId="{7129AFE6-2303-4CE4-8200-A004DD436F97}"/>
-          </ac:spMkLst>
-        </pc:spChg>
-        <pc:spChg chg="mod">
-          <ac:chgData name="Mitchell Wand" userId="de9b44c55c049659" providerId="LiveId" clId="{1B3D1EA2-D633-4A89-BCEE-7757CCB4FD42}" dt="2023-01-07T17:09:45.903" v="17" actId="14100"/>
-          <ac:spMkLst>
-            <pc:docMk/>
-            <pc:sldMk cId="915762083" sldId="361"/>
-            <ac:spMk id="8" creationId="{D13C1BAE-F029-4CC7-BCA5-8575A6ECA773}"/>
-          </ac:spMkLst>
-        </pc:spChg>
-      </pc:sldChg>
-      <pc:sldChg chg="modSp mod">
-        <pc:chgData name="Mitchell Wand" userId="de9b44c55c049659" providerId="LiveId" clId="{1B3D1EA2-D633-4A89-BCEE-7757CCB4FD42}" dt="2023-01-07T17:10:56.560" v="22" actId="14100"/>
-        <pc:sldMkLst>
-          <pc:docMk/>
-          <pc:sldMk cId="2175689014" sldId="363"/>
-        </pc:sldMkLst>
-        <pc:spChg chg="mod">
-          <ac:chgData name="Mitchell Wand" userId="de9b44c55c049659" providerId="LiveId" clId="{1B3D1EA2-D633-4A89-BCEE-7757CCB4FD42}" dt="2023-01-07T17:10:47.559" v="21"/>
-          <ac:spMkLst>
-            <pc:docMk/>
-            <pc:sldMk cId="2175689014" sldId="363"/>
-            <ac:spMk id="6" creationId="{C57EF10A-F451-4D47-B00A-2D711BE90266}"/>
-          </ac:spMkLst>
-        </pc:spChg>
-        <pc:spChg chg="mod">
-          <ac:chgData name="Mitchell Wand" userId="de9b44c55c049659" providerId="LiveId" clId="{1B3D1EA2-D633-4A89-BCEE-7757CCB4FD42}" dt="2023-01-07T17:10:56.560" v="22" actId="14100"/>
-          <ac:spMkLst>
-            <pc:docMk/>
-            <pc:sldMk cId="2175689014" sldId="363"/>
-            <ac:spMk id="7" creationId="{43742CDD-C1E7-4BBA-89C5-767A9BCB1EEB}"/>
-          </ac:spMkLst>
-        </pc:spChg>
-      </pc:sldChg>
-      <pc:sldChg chg="modNotes">
-        <pc:chgData name="Mitchell Wand" userId="de9b44c55c049659" providerId="LiveId" clId="{1B3D1EA2-D633-4A89-BCEE-7757CCB4FD42}" dt="2023-01-07T17:09:36.780" v="16"/>
-        <pc:sldMkLst>
-          <pc:docMk/>
-          <pc:sldMk cId="3947735393" sldId="365"/>
-        </pc:sldMkLst>
-      </pc:sldChg>
-      <pc:sldChg chg="modSp mod modNotes">
-        <pc:chgData name="Mitchell Wand" userId="de9b44c55c049659" providerId="LiveId" clId="{1B3D1EA2-D633-4A89-BCEE-7757CCB4FD42}" dt="2023-01-07T17:12:02.572" v="26" actId="14100"/>
-        <pc:sldMkLst>
-          <pc:docMk/>
-          <pc:sldMk cId="1583029545" sldId="369"/>
-        </pc:sldMkLst>
-        <pc:spChg chg="mod">
-          <ac:chgData name="Mitchell Wand" userId="de9b44c55c049659" providerId="LiveId" clId="{1B3D1EA2-D633-4A89-BCEE-7757CCB4FD42}" dt="2023-01-07T17:12:02.572" v="26" actId="14100"/>
-          <ac:spMkLst>
-            <pc:docMk/>
-            <pc:sldMk cId="1583029545" sldId="369"/>
-            <ac:spMk id="6" creationId="{BD40DC19-940C-4417-B7DE-E77FCDC9039E}"/>
-          </ac:spMkLst>
-        </pc:spChg>
-        <pc:spChg chg="mod">
-          <ac:chgData name="Mitchell Wand" userId="de9b44c55c049659" providerId="LiveId" clId="{1B3D1EA2-D633-4A89-BCEE-7757CCB4FD42}" dt="2023-01-07T17:10:47.559" v="21"/>
-          <ac:spMkLst>
-            <pc:docMk/>
-            <pc:sldMk cId="1583029545" sldId="369"/>
-            <ac:spMk id="10" creationId="{6050C85E-D369-42A5-BF5F-D710CEBA79BF}"/>
-          </ac:spMkLst>
-        </pc:spChg>
-      </pc:sldChg>
-      <pc:sldChg chg="modSp mod">
-        <pc:chgData name="Mitchell Wand" userId="de9b44c55c049659" providerId="LiveId" clId="{1B3D1EA2-D633-4A89-BCEE-7757CCB4FD42}" dt="2023-01-07T17:11:52.397" v="25" actId="20577"/>
-        <pc:sldMkLst>
-          <pc:docMk/>
-          <pc:sldMk cId="1017021096" sldId="371"/>
-        </pc:sldMkLst>
-        <pc:spChg chg="mod">
-          <ac:chgData name="Mitchell Wand" userId="de9b44c55c049659" providerId="LiveId" clId="{1B3D1EA2-D633-4A89-BCEE-7757CCB4FD42}" dt="2023-01-07T17:11:52.397" v="25" actId="20577"/>
-          <ac:spMkLst>
-            <pc:docMk/>
-            <pc:sldMk cId="1017021096" sldId="371"/>
-            <ac:spMk id="3" creationId="{752C0810-2FED-46EB-82B7-B2730F69E5BB}"/>
-          </ac:spMkLst>
-        </pc:spChg>
-      </pc:sldChg>
-      <pc:sldChg chg="modSp">
-        <pc:chgData name="Mitchell Wand" userId="de9b44c55c049659" providerId="LiveId" clId="{1B3D1EA2-D633-4A89-BCEE-7757CCB4FD42}" dt="2023-01-07T17:10:47.559" v="21"/>
-        <pc:sldMkLst>
-          <pc:docMk/>
-          <pc:sldMk cId="4285197496" sldId="374"/>
-        </pc:sldMkLst>
-        <pc:spChg chg="mod">
-          <ac:chgData name="Mitchell Wand" userId="de9b44c55c049659" providerId="LiveId" clId="{1B3D1EA2-D633-4A89-BCEE-7757CCB4FD42}" dt="2023-01-07T17:10:47.559" v="21"/>
-          <ac:spMkLst>
-            <pc:docMk/>
-            <pc:sldMk cId="4285197496" sldId="374"/>
-            <ac:spMk id="2" creationId="{1078B5ED-089E-4E03-AE7A-2333C7AF4560}"/>
-          </ac:spMkLst>
-        </pc:spChg>
-        <pc:spChg chg="mod">
-          <ac:chgData name="Mitchell Wand" userId="de9b44c55c049659" providerId="LiveId" clId="{1B3D1EA2-D633-4A89-BCEE-7757CCB4FD42}" dt="2023-01-07T17:10:47.559" v="21"/>
-          <ac:spMkLst>
-            <pc:docMk/>
-            <pc:sldMk cId="4285197496" sldId="374"/>
-            <ac:spMk id="6" creationId="{0F71FA50-933F-4201-87ED-4334941A29AD}"/>
-          </ac:spMkLst>
-        </pc:spChg>
-      </pc:sldChg>
-      <pc:sldChg chg="modSp mod">
-        <pc:chgData name="Mitchell Wand" userId="de9b44c55c049659" providerId="LiveId" clId="{1B3D1EA2-D633-4A89-BCEE-7757CCB4FD42}" dt="2023-01-07T17:08:16.959" v="14" actId="20577"/>
-        <pc:sldMkLst>
-          <pc:docMk/>
-          <pc:sldMk cId="2452429264" sldId="379"/>
-        </pc:sldMkLst>
-        <pc:spChg chg="mod">
-          <ac:chgData name="Mitchell Wand" userId="de9b44c55c049659" providerId="LiveId" clId="{1B3D1EA2-D633-4A89-BCEE-7757CCB4FD42}" dt="2023-01-07T17:07:55.574" v="0" actId="20577"/>
-          <ac:spMkLst>
-            <pc:docMk/>
-            <pc:sldMk cId="2452429264" sldId="379"/>
-            <ac:spMk id="2" creationId="{40765BC5-92E6-4F5A-B981-1C5EE975861B}"/>
-          </ac:spMkLst>
-        </pc:spChg>
-        <pc:spChg chg="mod">
-          <ac:chgData name="Mitchell Wand" userId="de9b44c55c049659" providerId="LiveId" clId="{1B3D1EA2-D633-4A89-BCEE-7757CCB4FD42}" dt="2023-01-07T17:08:16.959" v="14" actId="20577"/>
-          <ac:spMkLst>
-            <pc:docMk/>
-            <pc:sldMk cId="2452429264" sldId="379"/>
-            <ac:spMk id="3" creationId="{3B7BC06A-54D1-4D10-B536-9DF33B2C3997}"/>
-          </ac:spMkLst>
-        </pc:spChg>
-        <pc:spChg chg="mod">
-          <ac:chgData name="Mitchell Wand" userId="de9b44c55c049659" providerId="LiveId" clId="{1B3D1EA2-D633-4A89-BCEE-7757CCB4FD42}" dt="2023-01-07T17:08:12.093" v="12" actId="20577"/>
-          <ac:spMkLst>
-            <pc:docMk/>
-            <pc:sldMk cId="2452429264" sldId="379"/>
-            <ac:spMk id="8" creationId="{5B356C44-32EB-4AC4-94B7-A86895491E70}"/>
-          </ac:spMkLst>
-        </pc:spChg>
-      </pc:sldChg>
-      <pc:sldChg chg="modNotesTx">
-        <pc:chgData name="Mitchell Wand" userId="de9b44c55c049659" providerId="LiveId" clId="{1B3D1EA2-D633-4A89-BCEE-7757CCB4FD42}" dt="2023-01-07T17:13:38.282" v="157" actId="20577"/>
-        <pc:sldMkLst>
-          <pc:docMk/>
-          <pc:sldMk cId="3345968335" sldId="430"/>
-        </pc:sldMkLst>
-      </pc:sldChg>
-    </pc:docChg>
-  </pc:docChgLst>
-  <pc:docChgLst>
-    <pc:chgData name="Mitchell Wand" userId="de9b44c55c049659" providerId="LiveId" clId="{AD6466CF-1D05-4372-95BC-7089371C5C94}"/>
-    <pc:docChg chg="modSld">
-      <pc:chgData name="Mitchell Wand" userId="de9b44c55c049659" providerId="LiveId" clId="{AD6466CF-1D05-4372-95BC-7089371C5C94}" dt="2023-01-23T20:10:58.486" v="76" actId="20577"/>
-      <pc:docMkLst>
-        <pc:docMk/>
-      </pc:docMkLst>
-      <pc:sldChg chg="modSp mod">
-        <pc:chgData name="Mitchell Wand" userId="de9b44c55c049659" providerId="LiveId" clId="{AD6466CF-1D05-4372-95BC-7089371C5C94}" dt="2023-01-23T20:08:10.967" v="0" actId="14100"/>
-        <pc:sldMkLst>
-          <pc:docMk/>
-          <pc:sldMk cId="915762083" sldId="361"/>
-        </pc:sldMkLst>
-        <pc:spChg chg="mod">
-          <ac:chgData name="Mitchell Wand" userId="de9b44c55c049659" providerId="LiveId" clId="{AD6466CF-1D05-4372-95BC-7089371C5C94}" dt="2023-01-23T20:08:10.967" v="0" actId="14100"/>
-          <ac:spMkLst>
-            <pc:docMk/>
-            <pc:sldMk cId="915762083" sldId="361"/>
-            <ac:spMk id="6" creationId="{7129AFE6-2303-4CE4-8200-A004DD436F97}"/>
-          </ac:spMkLst>
-        </pc:spChg>
-      </pc:sldChg>
-      <pc:sldChg chg="modSp">
-        <pc:chgData name="Mitchell Wand" userId="de9b44c55c049659" providerId="LiveId" clId="{AD6466CF-1D05-4372-95BC-7089371C5C94}" dt="2023-01-23T20:08:19.858" v="2" actId="20577"/>
-        <pc:sldMkLst>
-          <pc:docMk/>
-          <pc:sldMk cId="3247464670" sldId="362"/>
-        </pc:sldMkLst>
-        <pc:spChg chg="mod">
-          <ac:chgData name="Mitchell Wand" userId="de9b44c55c049659" providerId="LiveId" clId="{AD6466CF-1D05-4372-95BC-7089371C5C94}" dt="2023-01-23T20:08:19.858" v="2" actId="20577"/>
-          <ac:spMkLst>
-            <pc:docMk/>
-            <pc:sldMk cId="3247464670" sldId="362"/>
-            <ac:spMk id="6" creationId="{AEB2F578-F41C-42BE-A746-B411D0AE37EB}"/>
-          </ac:spMkLst>
-        </pc:spChg>
-      </pc:sldChg>
-      <pc:sldChg chg="modSp mod">
-        <pc:chgData name="Mitchell Wand" userId="de9b44c55c049659" providerId="LiveId" clId="{AD6466CF-1D05-4372-95BC-7089371C5C94}" dt="2023-01-23T20:08:49.998" v="9" actId="20577"/>
-        <pc:sldMkLst>
-          <pc:docMk/>
-          <pc:sldMk cId="3947735393" sldId="365"/>
-        </pc:sldMkLst>
-        <pc:spChg chg="mod">
-          <ac:chgData name="Mitchell Wand" userId="de9b44c55c049659" providerId="LiveId" clId="{AD6466CF-1D05-4372-95BC-7089371C5C94}" dt="2023-01-23T20:08:49.998" v="9" actId="20577"/>
-          <ac:spMkLst>
-            <pc:docMk/>
-            <pc:sldMk cId="3947735393" sldId="365"/>
-            <ac:spMk id="7" creationId="{A694B6C8-5A57-35D8-E740-C16FA3796D1E}"/>
-          </ac:spMkLst>
-        </pc:spChg>
-      </pc:sldChg>
-      <pc:sldChg chg="modSp mod">
-        <pc:chgData name="Mitchell Wand" userId="de9b44c55c049659" providerId="LiveId" clId="{AD6466CF-1D05-4372-95BC-7089371C5C94}" dt="2023-01-23T20:09:35.924" v="34" actId="20577"/>
+        <pc:chgData name="Mitchell Wand" userId="de9b44c55c049659" providerId="LiveId" clId="{7A9D5940-B2CC-47DD-AF5E-71219F1A1E26}" dt="2026-09-29T00:17:24.624" v="12" actId="20577"/>
         <pc:sldMkLst>
           <pc:docMk/>
           <pc:sldMk cId="2468871028" sldId="370"/>
         </pc:sldMkLst>
         <pc:spChg chg="mod">
-          <ac:chgData name="Mitchell Wand" userId="de9b44c55c049659" providerId="LiveId" clId="{AD6466CF-1D05-4372-95BC-7089371C5C94}" dt="2023-01-23T20:09:35.924" v="34" actId="20577"/>
+          <ac:chgData name="Mitchell Wand" userId="de9b44c55c049659" providerId="LiveId" clId="{7A9D5940-B2CC-47DD-AF5E-71219F1A1E26}" dt="2026-09-29T00:17:16.876" v="6" actId="20577"/>
           <ac:spMkLst>
             <pc:docMk/>
             <pc:sldMk cId="2468871028" sldId="370"/>
-            <ac:spMk id="5" creationId="{9A240F55-B2AC-4A29-B17F-8DEA798DAAE4}"/>
-          </ac:spMkLst>
-        </pc:spChg>
-      </pc:sldChg>
-      <pc:sldChg chg="modSp mod">
-        <pc:chgData name="Mitchell Wand" userId="de9b44c55c049659" providerId="LiveId" clId="{AD6466CF-1D05-4372-95BC-7089371C5C94}" dt="2023-01-23T20:09:56.370" v="36" actId="20577"/>
-        <pc:sldMkLst>
-          <pc:docMk/>
-          <pc:sldMk cId="1017021096" sldId="371"/>
-        </pc:sldMkLst>
-        <pc:spChg chg="mod">
-          <ac:chgData name="Mitchell Wand" userId="de9b44c55c049659" providerId="LiveId" clId="{AD6466CF-1D05-4372-95BC-7089371C5C94}" dt="2023-01-23T20:09:56.370" v="36" actId="20577"/>
-          <ac:spMkLst>
-            <pc:docMk/>
-            <pc:sldMk cId="1017021096" sldId="371"/>
-            <ac:spMk id="3" creationId="{752C0810-2FED-46EB-82B7-B2730F69E5BB}"/>
-          </ac:spMkLst>
-        </pc:spChg>
-      </pc:sldChg>
-      <pc:sldChg chg="modSp mod">
-        <pc:chgData name="Mitchell Wand" userId="de9b44c55c049659" providerId="LiveId" clId="{AD6466CF-1D05-4372-95BC-7089371C5C94}" dt="2023-01-23T20:10:35.781" v="66" actId="20577"/>
-        <pc:sldMkLst>
-          <pc:docMk/>
-          <pc:sldMk cId="4285197496" sldId="374"/>
-        </pc:sldMkLst>
-        <pc:spChg chg="mod">
-          <ac:chgData name="Mitchell Wand" userId="de9b44c55c049659" providerId="LiveId" clId="{AD6466CF-1D05-4372-95BC-7089371C5C94}" dt="2023-01-23T20:10:13.976" v="39" actId="20577"/>
-          <ac:spMkLst>
-            <pc:docMk/>
-            <pc:sldMk cId="4285197496" sldId="374"/>
-            <ac:spMk id="2" creationId="{1078B5ED-089E-4E03-AE7A-2333C7AF4560}"/>
-          </ac:spMkLst>
-        </pc:spChg>
-        <pc:spChg chg="mod">
-          <ac:chgData name="Mitchell Wand" userId="de9b44c55c049659" providerId="LiveId" clId="{AD6466CF-1D05-4372-95BC-7089371C5C94}" dt="2023-01-23T20:10:29.660" v="57" actId="20577"/>
-          <ac:spMkLst>
-            <pc:docMk/>
-            <pc:sldMk cId="4285197496" sldId="374"/>
-            <ac:spMk id="5" creationId="{F1372F46-A124-4B14-8F16-E2C13171ECB3}"/>
-          </ac:spMkLst>
-        </pc:spChg>
-        <pc:spChg chg="mod">
-          <ac:chgData name="Mitchell Wand" userId="de9b44c55c049659" providerId="LiveId" clId="{AD6466CF-1D05-4372-95BC-7089371C5C94}" dt="2023-01-23T20:10:35.781" v="66" actId="20577"/>
-          <ac:spMkLst>
-            <pc:docMk/>
-            <pc:sldMk cId="4285197496" sldId="374"/>
-            <ac:spMk id="6" creationId="{0F71FA50-933F-4201-87ED-4334941A29AD}"/>
-          </ac:spMkLst>
-        </pc:spChg>
-      </pc:sldChg>
-      <pc:sldChg chg="modSp mod">
-        <pc:chgData name="Mitchell Wand" userId="de9b44c55c049659" providerId="LiveId" clId="{AD6466CF-1D05-4372-95BC-7089371C5C94}" dt="2023-01-23T20:10:58.486" v="76" actId="20577"/>
-        <pc:sldMkLst>
-          <pc:docMk/>
-          <pc:sldMk cId="2659888623" sldId="375"/>
-        </pc:sldMkLst>
-        <pc:spChg chg="mod">
-          <ac:chgData name="Mitchell Wand" userId="de9b44c55c049659" providerId="LiveId" clId="{AD6466CF-1D05-4372-95BC-7089371C5C94}" dt="2023-01-23T20:10:58.486" v="76" actId="20577"/>
-          <ac:spMkLst>
-            <pc:docMk/>
-            <pc:sldMk cId="2659888623" sldId="375"/>
-            <ac:spMk id="5" creationId="{8736CE8B-3D4E-4A1D-A9EF-4C9EFEAD593A}"/>
-          </ac:spMkLst>
-        </pc:spChg>
-      </pc:sldChg>
-      <pc:sldChg chg="modSp mod">
-        <pc:chgData name="Mitchell Wand" userId="de9b44c55c049659" providerId="LiveId" clId="{AD6466CF-1D05-4372-95BC-7089371C5C94}" dt="2023-01-23T20:09:02.432" v="12" actId="20577"/>
-        <pc:sldMkLst>
-          <pc:docMk/>
-          <pc:sldMk cId="2869151381" sldId="494"/>
-        </pc:sldMkLst>
-        <pc:spChg chg="mod">
-          <ac:chgData name="Mitchell Wand" userId="de9b44c55c049659" providerId="LiveId" clId="{AD6466CF-1D05-4372-95BC-7089371C5C94}" dt="2023-01-23T20:09:02.432" v="12" actId="20577"/>
-          <ac:spMkLst>
-            <pc:docMk/>
-            <pc:sldMk cId="2869151381" sldId="494"/>
-            <ac:spMk id="5" creationId="{7A7CE241-579A-C00B-2C03-8055423915D5}"/>
-          </ac:spMkLst>
-        </pc:spChg>
-      </pc:sldChg>
-    </pc:docChg>
-  </pc:docChgLst>
-  <pc:docChgLst>
-    <pc:chgData name="Mitchell Wand" userId="de9b44c55c049659" providerId="LiveId" clId="{2F0674E9-A568-49F0-A150-6793737DAAAA}"/>
-    <pc:docChg chg="modSld">
-      <pc:chgData name="Mitchell Wand" userId="de9b44c55c049659" providerId="LiveId" clId="{2F0674E9-A568-49F0-A150-6793737DAAAA}" dt="2022-09-09T15:08:48.608" v="0" actId="20577"/>
-      <pc:docMkLst>
-        <pc:docMk/>
-      </pc:docMkLst>
-      <pc:sldChg chg="modSp mod">
-        <pc:chgData name="Mitchell Wand" userId="de9b44c55c049659" providerId="LiveId" clId="{2F0674E9-A568-49F0-A150-6793737DAAAA}" dt="2022-09-09T15:08:48.608" v="0" actId="20577"/>
-        <pc:sldMkLst>
-          <pc:docMk/>
-          <pc:sldMk cId="2452429264" sldId="379"/>
-        </pc:sldMkLst>
-        <pc:spChg chg="mod">
-          <ac:chgData name="Mitchell Wand" userId="de9b44c55c049659" providerId="LiveId" clId="{2F0674E9-A568-49F0-A150-6793737DAAAA}" dt="2022-09-09T15:08:48.608" v="0" actId="20577"/>
-          <ac:spMkLst>
-            <pc:docMk/>
-            <pc:sldMk cId="2452429264" sldId="379"/>
-            <ac:spMk id="2" creationId="{40765BC5-92E6-4F5A-B981-1C5EE975861B}"/>
-          </ac:spMkLst>
-        </pc:spChg>
-      </pc:sldChg>
-    </pc:docChg>
-  </pc:docChgLst>
-  <pc:docChgLst>
-    <pc:chgData name="Mitchell Wand" userId="de9b44c55c049659" providerId="LiveId" clId="{D78B7B3A-D6AA-410A-8F9F-ED7CF0BCC52D}"/>
-    <pc:docChg chg="undo custSel addSld delSld modSld sldOrd">
-      <pc:chgData name="Mitchell Wand" userId="de9b44c55c049659" providerId="LiveId" clId="{D78B7B3A-D6AA-410A-8F9F-ED7CF0BCC52D}" dt="2024-09-09T17:22:37.120" v="2454" actId="20577"/>
-      <pc:docMkLst>
-        <pc:docMk/>
-      </pc:docMkLst>
-      <pc:sldChg chg="modNotesTx">
-        <pc:chgData name="Mitchell Wand" userId="de9b44c55c049659" providerId="LiveId" clId="{D78B7B3A-D6AA-410A-8F9F-ED7CF0BCC52D}" dt="2024-09-09T16:51:51.621" v="1593" actId="20577"/>
-        <pc:sldMkLst>
-          <pc:docMk/>
-          <pc:sldMk cId="727596403" sldId="357"/>
-        </pc:sldMkLst>
-      </pc:sldChg>
-      <pc:sldChg chg="modNotesTx">
-        <pc:chgData name="Mitchell Wand" userId="de9b44c55c049659" providerId="LiveId" clId="{D78B7B3A-D6AA-410A-8F9F-ED7CF0BCC52D}" dt="2024-09-09T16:57:47.177" v="1934" actId="20577"/>
-        <pc:sldMkLst>
-          <pc:docMk/>
-          <pc:sldMk cId="2175689014" sldId="363"/>
-        </pc:sldMkLst>
-      </pc:sldChg>
-      <pc:sldChg chg="modNotesTx">
-        <pc:chgData name="Mitchell Wand" userId="de9b44c55c049659" providerId="LiveId" clId="{D78B7B3A-D6AA-410A-8F9F-ED7CF0BCC52D}" dt="2024-09-09T17:09:59.567" v="2285" actId="20577"/>
-        <pc:sldMkLst>
-          <pc:docMk/>
-          <pc:sldMk cId="2468871028" sldId="370"/>
-        </pc:sldMkLst>
-      </pc:sldChg>
-      <pc:sldChg chg="modNotesTx">
-        <pc:chgData name="Mitchell Wand" userId="de9b44c55c049659" providerId="LiveId" clId="{D78B7B3A-D6AA-410A-8F9F-ED7CF0BCC52D}" dt="2024-09-09T17:22:37.120" v="2454" actId="20577"/>
-        <pc:sldMkLst>
-          <pc:docMk/>
-          <pc:sldMk cId="2659888623" sldId="375"/>
-        </pc:sldMkLst>
-      </pc:sldChg>
-      <pc:sldChg chg="modSp mod">
-        <pc:chgData name="Mitchell Wand" userId="de9b44c55c049659" providerId="LiveId" clId="{D78B7B3A-D6AA-410A-8F9F-ED7CF0BCC52D}" dt="2024-09-07T21:10:01.532" v="22" actId="20577"/>
-        <pc:sldMkLst>
-          <pc:docMk/>
-          <pc:sldMk cId="2452429264" sldId="379"/>
-        </pc:sldMkLst>
-        <pc:spChg chg="mod">
-          <ac:chgData name="Mitchell Wand" userId="de9b44c55c049659" providerId="LiveId" clId="{D78B7B3A-D6AA-410A-8F9F-ED7CF0BCC52D}" dt="2024-09-07T21:10:01.532" v="22" actId="20577"/>
-          <ac:spMkLst>
-            <pc:docMk/>
-            <pc:sldMk cId="2452429264" sldId="379"/>
-            <ac:spMk id="2" creationId="{40765BC5-92E6-4F5A-B981-1C5EE975861B}"/>
-          </ac:spMkLst>
-        </pc:spChg>
-      </pc:sldChg>
-      <pc:sldChg chg="addSp delSp modSp mod">
-        <pc:chgData name="Mitchell Wand" userId="de9b44c55c049659" providerId="LiveId" clId="{D78B7B3A-D6AA-410A-8F9F-ED7CF0BCC52D}" dt="2024-09-09T17:07:00.857" v="2005" actId="255"/>
-        <pc:sldMkLst>
-          <pc:docMk/>
-          <pc:sldMk cId="2869151381" sldId="494"/>
-        </pc:sldMkLst>
-        <pc:spChg chg="del">
-          <ac:chgData name="Mitchell Wand" userId="de9b44c55c049659" providerId="LiveId" clId="{D78B7B3A-D6AA-410A-8F9F-ED7CF0BCC52D}" dt="2024-09-09T17:06:06.179" v="2001" actId="478"/>
-          <ac:spMkLst>
-            <pc:docMk/>
-            <pc:sldMk cId="2869151381" sldId="494"/>
-            <ac:spMk id="5" creationId="{7A7CE241-579A-C00B-2C03-8055423915D5}"/>
-          </ac:spMkLst>
-        </pc:spChg>
-        <pc:spChg chg="mod">
-          <ac:chgData name="Mitchell Wand" userId="de9b44c55c049659" providerId="LiveId" clId="{D78B7B3A-D6AA-410A-8F9F-ED7CF0BCC52D}" dt="2024-09-09T17:07:00.857" v="2005" actId="255"/>
-          <ac:spMkLst>
-            <pc:docMk/>
-            <pc:sldMk cId="2869151381" sldId="494"/>
-            <ac:spMk id="7" creationId="{FAFEFC8B-3907-442E-9BD2-C4A00E794F9E}"/>
-          </ac:spMkLst>
-        </pc:spChg>
-        <pc:spChg chg="add del">
-          <ac:chgData name="Mitchell Wand" userId="de9b44c55c049659" providerId="LiveId" clId="{D78B7B3A-D6AA-410A-8F9F-ED7CF0BCC52D}" dt="2024-09-09T17:06:15.492" v="2003" actId="22"/>
-          <ac:spMkLst>
-            <pc:docMk/>
-            <pc:sldMk cId="2869151381" sldId="494"/>
-            <ac:spMk id="14" creationId="{33481FC7-AFA6-B1C5-66A0-29C10956385E}"/>
-          </ac:spMkLst>
-        </pc:spChg>
-      </pc:sldChg>
-      <pc:sldChg chg="modSp mod modNotesTx">
-        <pc:chgData name="Mitchell Wand" userId="de9b44c55c049659" providerId="LiveId" clId="{D78B7B3A-D6AA-410A-8F9F-ED7CF0BCC52D}" dt="2024-09-09T17:08:45.165" v="2235" actId="20577"/>
-        <pc:sldMkLst>
-          <pc:docMk/>
-          <pc:sldMk cId="3605028067" sldId="495"/>
-        </pc:sldMkLst>
-        <pc:spChg chg="mod">
-          <ac:chgData name="Mitchell Wand" userId="de9b44c55c049659" providerId="LiveId" clId="{D78B7B3A-D6AA-410A-8F9F-ED7CF0BCC52D}" dt="2024-09-09T17:07:19.397" v="2007" actId="20577"/>
-          <ac:spMkLst>
-            <pc:docMk/>
-            <pc:sldMk cId="3605028067" sldId="495"/>
-            <ac:spMk id="2" creationId="{BA745527-D100-4B4F-829D-1B696CAF1C9B}"/>
-          </ac:spMkLst>
-        </pc:spChg>
-      </pc:sldChg>
-      <pc:sldChg chg="del">
-        <pc:chgData name="Mitchell Wand" userId="de9b44c55c049659" providerId="LiveId" clId="{D78B7B3A-D6AA-410A-8F9F-ED7CF0BCC52D}" dt="2024-09-09T16:47:43.715" v="1367" actId="2696"/>
-        <pc:sldMkLst>
-          <pc:docMk/>
-          <pc:sldMk cId="657427070" sldId="496"/>
-        </pc:sldMkLst>
-      </pc:sldChg>
-      <pc:sldChg chg="add del">
-        <pc:chgData name="Mitchell Wand" userId="de9b44c55c049659" providerId="LiveId" clId="{D78B7B3A-D6AA-410A-8F9F-ED7CF0BCC52D}" dt="2024-09-09T16:50:12.904" v="1377" actId="2696"/>
-        <pc:sldMkLst>
-          <pc:docMk/>
-          <pc:sldMk cId="1198500969" sldId="497"/>
-        </pc:sldMkLst>
-      </pc:sldChg>
-      <pc:sldChg chg="add del">
-        <pc:chgData name="Mitchell Wand" userId="de9b44c55c049659" providerId="LiveId" clId="{D78B7B3A-D6AA-410A-8F9F-ED7CF0BCC52D}" dt="2024-09-09T16:50:12.904" v="1377" actId="2696"/>
-        <pc:sldMkLst>
-          <pc:docMk/>
-          <pc:sldMk cId="2839435653" sldId="498"/>
-        </pc:sldMkLst>
-      </pc:sldChg>
-      <pc:sldChg chg="add del">
-        <pc:chgData name="Mitchell Wand" userId="de9b44c55c049659" providerId="LiveId" clId="{D78B7B3A-D6AA-410A-8F9F-ED7CF0BCC52D}" dt="2024-09-09T16:50:12.904" v="1377" actId="2696"/>
-        <pc:sldMkLst>
-          <pc:docMk/>
-          <pc:sldMk cId="4155274164" sldId="499"/>
-        </pc:sldMkLst>
-      </pc:sldChg>
-      <pc:sldChg chg="add del">
-        <pc:chgData name="Mitchell Wand" userId="de9b44c55c049659" providerId="LiveId" clId="{D78B7B3A-D6AA-410A-8F9F-ED7CF0BCC52D}" dt="2024-09-09T16:50:12.904" v="1377" actId="2696"/>
-        <pc:sldMkLst>
-          <pc:docMk/>
-          <pc:sldMk cId="830561614" sldId="501"/>
-        </pc:sldMkLst>
-      </pc:sldChg>
-      <pc:sldChg chg="modSp mod">
-        <pc:chgData name="Mitchell Wand" userId="de9b44c55c049659" providerId="LiveId" clId="{D78B7B3A-D6AA-410A-8F9F-ED7CF0BCC52D}" dt="2024-09-09T16:29:25.748" v="712" actId="20577"/>
-        <pc:sldMkLst>
-          <pc:docMk/>
-          <pc:sldMk cId="1442055128" sldId="502"/>
-        </pc:sldMkLst>
-        <pc:spChg chg="mod">
-          <ac:chgData name="Mitchell Wand" userId="de9b44c55c049659" providerId="LiveId" clId="{D78B7B3A-D6AA-410A-8F9F-ED7CF0BCC52D}" dt="2024-09-09T16:29:25.748" v="712" actId="20577"/>
-          <ac:spMkLst>
-            <pc:docMk/>
-            <pc:sldMk cId="1442055128" sldId="502"/>
-            <ac:spMk id="3" creationId="{7DA1792B-5C39-2F36-7ABD-EA0A3AD3A86B}"/>
-          </ac:spMkLst>
-        </pc:spChg>
-      </pc:sldChg>
-      <pc:sldChg chg="add del">
-        <pc:chgData name="Mitchell Wand" userId="de9b44c55c049659" providerId="LiveId" clId="{D78B7B3A-D6AA-410A-8F9F-ED7CF0BCC52D}" dt="2024-09-09T16:50:12.904" v="1377" actId="2696"/>
-        <pc:sldMkLst>
-          <pc:docMk/>
-          <pc:sldMk cId="3512688338" sldId="504"/>
-        </pc:sldMkLst>
-      </pc:sldChg>
-      <pc:sldChg chg="modSp mod ord modAnim modShow modNotesTx">
-        <pc:chgData name="Mitchell Wand" userId="de9b44c55c049659" providerId="LiveId" clId="{D78B7B3A-D6AA-410A-8F9F-ED7CF0BCC52D}" dt="2024-09-09T16:30:17.460" v="789" actId="20577"/>
-        <pc:sldMkLst>
-          <pc:docMk/>
-          <pc:sldMk cId="935629653" sldId="506"/>
-        </pc:sldMkLst>
-        <pc:spChg chg="mod">
-          <ac:chgData name="Mitchell Wand" userId="de9b44c55c049659" providerId="LiveId" clId="{D78B7B3A-D6AA-410A-8F9F-ED7CF0BCC52D}" dt="2024-09-09T16:29:37.788" v="718" actId="20577"/>
-          <ac:spMkLst>
-            <pc:docMk/>
-            <pc:sldMk cId="935629653" sldId="506"/>
-            <ac:spMk id="2" creationId="{D91FA481-5614-D146-8F79-9881A75A3C88}"/>
-          </ac:spMkLst>
-        </pc:spChg>
-        <pc:spChg chg="mod">
-          <ac:chgData name="Mitchell Wand" userId="de9b44c55c049659" providerId="LiveId" clId="{D78B7B3A-D6AA-410A-8F9F-ED7CF0BCC52D}" dt="2024-09-09T16:29:03.024" v="700" actId="20577"/>
-          <ac:spMkLst>
-            <pc:docMk/>
-            <pc:sldMk cId="935629653" sldId="506"/>
-            <ac:spMk id="3" creationId="{078B7515-2DA5-EBBF-89F6-9B70B13E2987}"/>
-          </ac:spMkLst>
-        </pc:spChg>
-      </pc:sldChg>
-      <pc:sldChg chg="del">
-        <pc:chgData name="Mitchell Wand" userId="de9b44c55c049659" providerId="LiveId" clId="{D78B7B3A-D6AA-410A-8F9F-ED7CF0BCC52D}" dt="2024-09-09T16:52:23.038" v="1594" actId="2696"/>
-        <pc:sldMkLst>
-          <pc:docMk/>
-          <pc:sldMk cId="3566882518" sldId="507"/>
-        </pc:sldMkLst>
-      </pc:sldChg>
-      <pc:sldChg chg="modSp mod ord modNotesTx">
-        <pc:chgData name="Mitchell Wand" userId="de9b44c55c049659" providerId="LiveId" clId="{D78B7B3A-D6AA-410A-8F9F-ED7CF0BCC52D}" dt="2024-09-09T16:59:49.854" v="1991" actId="20577"/>
-        <pc:sldMkLst>
-          <pc:docMk/>
-          <pc:sldMk cId="3876617772" sldId="509"/>
-        </pc:sldMkLst>
-        <pc:spChg chg="mod">
-          <ac:chgData name="Mitchell Wand" userId="de9b44c55c049659" providerId="LiveId" clId="{D78B7B3A-D6AA-410A-8F9F-ED7CF0BCC52D}" dt="2024-09-09T16:59:49.854" v="1991" actId="20577"/>
-          <ac:spMkLst>
-            <pc:docMk/>
-            <pc:sldMk cId="3876617772" sldId="509"/>
-            <ac:spMk id="3" creationId="{3E798C6E-C139-AB5E-7FD9-0931096B7346}"/>
-          </ac:spMkLst>
-        </pc:spChg>
-      </pc:sldChg>
-      <pc:sldChg chg="addSp delSp modSp mod">
-        <pc:chgData name="Mitchell Wand" userId="de9b44c55c049659" providerId="LiveId" clId="{D78B7B3A-D6AA-410A-8F9F-ED7CF0BCC52D}" dt="2024-09-09T17:05:37.693" v="2000" actId="14100"/>
-        <pc:sldMkLst>
-          <pc:docMk/>
-          <pc:sldMk cId="919701592" sldId="511"/>
-        </pc:sldMkLst>
-        <pc:spChg chg="add mod">
-          <ac:chgData name="Mitchell Wand" userId="de9b44c55c049659" providerId="LiveId" clId="{D78B7B3A-D6AA-410A-8F9F-ED7CF0BCC52D}" dt="2024-09-09T17:05:37.693" v="2000" actId="14100"/>
-          <ac:spMkLst>
-            <pc:docMk/>
-            <pc:sldMk cId="919701592" sldId="511"/>
-            <ac:spMk id="5" creationId="{EA7F1B04-F26D-EED2-0C55-A5AB4E68A98F}"/>
-          </ac:spMkLst>
-        </pc:spChg>
-        <pc:spChg chg="del mod">
-          <ac:chgData name="Mitchell Wand" userId="de9b44c55c049659" providerId="LiveId" clId="{D78B7B3A-D6AA-410A-8F9F-ED7CF0BCC52D}" dt="2024-09-09T17:04:27.725" v="1993" actId="478"/>
-          <ac:spMkLst>
-            <pc:docMk/>
-            <pc:sldMk cId="919701592" sldId="511"/>
-            <ac:spMk id="10" creationId="{04363A5E-2D3F-45C1-480F-28CB0A26BF22}"/>
-          </ac:spMkLst>
-        </pc:spChg>
-      </pc:sldChg>
-      <pc:sldChg chg="modSp del mod modNotesTx">
-        <pc:chgData name="Mitchell Wand" userId="de9b44c55c049659" providerId="LiveId" clId="{D78B7B3A-D6AA-410A-8F9F-ED7CF0BCC52D}" dt="2024-09-09T16:31:44.105" v="823" actId="2696"/>
-        <pc:sldMkLst>
-          <pc:docMk/>
-          <pc:sldMk cId="3886575822" sldId="514"/>
-        </pc:sldMkLst>
-        <pc:spChg chg="mod">
-          <ac:chgData name="Mitchell Wand" userId="de9b44c55c049659" providerId="LiveId" clId="{D78B7B3A-D6AA-410A-8F9F-ED7CF0BCC52D}" dt="2024-09-07T21:10:53.786" v="47" actId="20577"/>
-          <ac:spMkLst>
-            <pc:docMk/>
-            <pc:sldMk cId="3886575822" sldId="514"/>
-            <ac:spMk id="2" creationId="{064924F3-F9B5-A558-3570-BF0F3B4B3C0C}"/>
-          </ac:spMkLst>
-        </pc:spChg>
-      </pc:sldChg>
-      <pc:sldChg chg="del">
-        <pc:chgData name="Mitchell Wand" userId="de9b44c55c049659" providerId="LiveId" clId="{D78B7B3A-D6AA-410A-8F9F-ED7CF0BCC52D}" dt="2024-09-09T16:47:58.045" v="1368" actId="2696"/>
-        <pc:sldMkLst>
-          <pc:docMk/>
-          <pc:sldMk cId="698929251" sldId="515"/>
-        </pc:sldMkLst>
-      </pc:sldChg>
-      <pc:sldChg chg="modSp add mod ord modNotesTx">
-        <pc:chgData name="Mitchell Wand" userId="de9b44c55c049659" providerId="LiveId" clId="{D78B7B3A-D6AA-410A-8F9F-ED7CF0BCC52D}" dt="2024-09-09T16:31:33.525" v="822" actId="20577"/>
-        <pc:sldMkLst>
-          <pc:docMk/>
-          <pc:sldMk cId="493322030" sldId="516"/>
-        </pc:sldMkLst>
-        <pc:spChg chg="mod">
-          <ac:chgData name="Mitchell Wand" userId="de9b44c55c049659" providerId="LiveId" clId="{D78B7B3A-D6AA-410A-8F9F-ED7CF0BCC52D}" dt="2024-09-09T16:27:18.465" v="653" actId="20577"/>
-          <ac:spMkLst>
-            <pc:docMk/>
-            <pc:sldMk cId="493322030" sldId="516"/>
-            <ac:spMk id="2" creationId="{064924F3-F9B5-A558-3570-BF0F3B4B3C0C}"/>
-          </ac:spMkLst>
-        </pc:spChg>
-      </pc:sldChg>
-      <pc:sldChg chg="addSp delSp modSp new add del mod modClrScheme modAnim chgLayout modNotesTx">
-        <pc:chgData name="Mitchell Wand" userId="de9b44c55c049659" providerId="LiveId" clId="{D78B7B3A-D6AA-410A-8F9F-ED7CF0BCC52D}" dt="2024-09-09T16:49:41.331" v="1376" actId="2696"/>
-        <pc:sldMkLst>
-          <pc:docMk/>
-          <pc:sldMk cId="3107106483" sldId="517"/>
-        </pc:sldMkLst>
-        <pc:spChg chg="mod ord">
-          <ac:chgData name="Mitchell Wand" userId="de9b44c55c049659" providerId="LiveId" clId="{D78B7B3A-D6AA-410A-8F9F-ED7CF0BCC52D}" dt="2024-09-09T16:37:13.060" v="867" actId="700"/>
-          <ac:spMkLst>
-            <pc:docMk/>
-            <pc:sldMk cId="3107106483" sldId="517"/>
-            <ac:spMk id="2" creationId="{5DBDA658-46F8-DEEA-AB13-6B214F56BE61}"/>
-          </ac:spMkLst>
-        </pc:spChg>
-        <pc:spChg chg="del">
-          <ac:chgData name="Mitchell Wand" userId="de9b44c55c049659" providerId="LiveId" clId="{D78B7B3A-D6AA-410A-8F9F-ED7CF0BCC52D}" dt="2024-09-09T16:37:13.060" v="867" actId="700"/>
-          <ac:spMkLst>
-            <pc:docMk/>
-            <pc:sldMk cId="3107106483" sldId="517"/>
-            <ac:spMk id="3" creationId="{DB2A1212-B8C3-D9FA-9265-567482BBCB10}"/>
-          </ac:spMkLst>
-        </pc:spChg>
-        <pc:spChg chg="mod ord">
-          <ac:chgData name="Mitchell Wand" userId="de9b44c55c049659" providerId="LiveId" clId="{D78B7B3A-D6AA-410A-8F9F-ED7CF0BCC52D}" dt="2024-09-09T16:37:13.060" v="867" actId="700"/>
-          <ac:spMkLst>
-            <pc:docMk/>
-            <pc:sldMk cId="3107106483" sldId="517"/>
-            <ac:spMk id="4" creationId="{96EECE79-B0FB-456F-D7E9-1E48474BD4AB}"/>
-          </ac:spMkLst>
-        </pc:spChg>
-        <pc:spChg chg="add del mod">
-          <ac:chgData name="Mitchell Wand" userId="de9b44c55c049659" providerId="LiveId" clId="{D78B7B3A-D6AA-410A-8F9F-ED7CF0BCC52D}" dt="2024-09-09T16:37:20.466" v="868" actId="478"/>
-          <ac:spMkLst>
-            <pc:docMk/>
-            <pc:sldMk cId="3107106483" sldId="517"/>
-            <ac:spMk id="6" creationId="{FDD08E09-DF74-EF72-B149-B1D45B1484CF}"/>
-          </ac:spMkLst>
-        </pc:spChg>
-        <pc:spChg chg="add del">
-          <ac:chgData name="Mitchell Wand" userId="de9b44c55c049659" providerId="LiveId" clId="{D78B7B3A-D6AA-410A-8F9F-ED7CF0BCC52D}" dt="2024-09-09T16:38:34.807" v="870" actId="22"/>
-          <ac:spMkLst>
-            <pc:docMk/>
-            <pc:sldMk cId="3107106483" sldId="517"/>
-            <ac:spMk id="8" creationId="{8AB01412-C931-1065-87EF-BBB3D0A9F9FE}"/>
-          </ac:spMkLst>
-        </pc:spChg>
-        <pc:spChg chg="add del">
-          <ac:chgData name="Mitchell Wand" userId="de9b44c55c049659" providerId="LiveId" clId="{D78B7B3A-D6AA-410A-8F9F-ED7CF0BCC52D}" dt="2024-09-09T16:38:41.421" v="872" actId="22"/>
-          <ac:spMkLst>
-            <pc:docMk/>
-            <pc:sldMk cId="3107106483" sldId="517"/>
-            <ac:spMk id="10" creationId="{D05A3D4C-26F3-FA5C-57F1-997EDE947444}"/>
-          </ac:spMkLst>
-        </pc:spChg>
-        <pc:spChg chg="add mod">
-          <ac:chgData name="Mitchell Wand" userId="de9b44c55c049659" providerId="LiveId" clId="{D78B7B3A-D6AA-410A-8F9F-ED7CF0BCC52D}" dt="2024-09-09T16:44:07.382" v="923" actId="2085"/>
-          <ac:spMkLst>
-            <pc:docMk/>
-            <pc:sldMk cId="3107106483" sldId="517"/>
-            <ac:spMk id="12" creationId="{231E930B-79DE-D471-722C-FFA225AD011F}"/>
-          </ac:spMkLst>
-        </pc:spChg>
-        <pc:spChg chg="add mod">
-          <ac:chgData name="Mitchell Wand" userId="de9b44c55c049659" providerId="LiveId" clId="{D78B7B3A-D6AA-410A-8F9F-ED7CF0BCC52D}" dt="2024-09-09T16:44:15.470" v="924" actId="2085"/>
-          <ac:spMkLst>
-            <pc:docMk/>
-            <pc:sldMk cId="3107106483" sldId="517"/>
-            <ac:spMk id="13" creationId="{044BBCF6-B4B1-4337-581B-F2474E865AD0}"/>
-          </ac:spMkLst>
-        </pc:spChg>
-        <pc:spChg chg="add mod">
-          <ac:chgData name="Mitchell Wand" userId="de9b44c55c049659" providerId="LiveId" clId="{D78B7B3A-D6AA-410A-8F9F-ED7CF0BCC52D}" dt="2024-09-09T16:44:41.621" v="927" actId="14100"/>
-          <ac:spMkLst>
-            <pc:docMk/>
-            <pc:sldMk cId="3107106483" sldId="517"/>
-            <ac:spMk id="14" creationId="{6E85235B-9B4C-9F1A-33D4-719D37C9A533}"/>
-          </ac:spMkLst>
-        </pc:spChg>
-      </pc:sldChg>
-      <pc:sldChg chg="addSp delSp modSp new mod modClrScheme chgLayout modNotesTx">
-        <pc:chgData name="Mitchell Wand" userId="de9b44c55c049659" providerId="LiveId" clId="{D78B7B3A-D6AA-410A-8F9F-ED7CF0BCC52D}" dt="2024-09-09T17:18:44.914" v="2430" actId="20577"/>
-        <pc:sldMkLst>
-          <pc:docMk/>
-          <pc:sldMk cId="2937310628" sldId="518"/>
-        </pc:sldMkLst>
-        <pc:spChg chg="mod ord">
-          <ac:chgData name="Mitchell Wand" userId="de9b44c55c049659" providerId="LiveId" clId="{D78B7B3A-D6AA-410A-8F9F-ED7CF0BCC52D}" dt="2024-09-09T17:17:09.478" v="2307" actId="700"/>
-          <ac:spMkLst>
-            <pc:docMk/>
-            <pc:sldMk cId="2937310628" sldId="518"/>
-            <ac:spMk id="2" creationId="{A21A93B4-5539-7823-2E57-E8B34FC391C1}"/>
-          </ac:spMkLst>
-        </pc:spChg>
-        <pc:spChg chg="del mod">
-          <ac:chgData name="Mitchell Wand" userId="de9b44c55c049659" providerId="LiveId" clId="{D78B7B3A-D6AA-410A-8F9F-ED7CF0BCC52D}" dt="2024-09-09T17:17:02.378" v="2306" actId="478"/>
-          <ac:spMkLst>
-            <pc:docMk/>
-            <pc:sldMk cId="2937310628" sldId="518"/>
-            <ac:spMk id="3" creationId="{CFD921EB-FB01-6A8F-3373-E9BCF6E77C78}"/>
-          </ac:spMkLst>
-        </pc:spChg>
-        <pc:spChg chg="mod ord">
-          <ac:chgData name="Mitchell Wand" userId="de9b44c55c049659" providerId="LiveId" clId="{D78B7B3A-D6AA-410A-8F9F-ED7CF0BCC52D}" dt="2024-09-09T17:17:09.478" v="2307" actId="700"/>
-          <ac:spMkLst>
-            <pc:docMk/>
-            <pc:sldMk cId="2937310628" sldId="518"/>
-            <ac:spMk id="4" creationId="{04799020-70FB-8902-8694-F2B04F713959}"/>
-          </ac:spMkLst>
-        </pc:spChg>
-        <pc:spChg chg="add del mod">
-          <ac:chgData name="Mitchell Wand" userId="de9b44c55c049659" providerId="LiveId" clId="{D78B7B3A-D6AA-410A-8F9F-ED7CF0BCC52D}" dt="2024-09-09T17:17:09.478" v="2307" actId="700"/>
-          <ac:spMkLst>
-            <pc:docMk/>
-            <pc:sldMk cId="2937310628" sldId="518"/>
-            <ac:spMk id="6" creationId="{98908C55-23BE-D8E6-7846-E676E40E8814}"/>
-          </ac:spMkLst>
-        </pc:spChg>
-        <pc:spChg chg="add mod">
-          <ac:chgData name="Mitchell Wand" userId="de9b44c55c049659" providerId="LiveId" clId="{D78B7B3A-D6AA-410A-8F9F-ED7CF0BCC52D}" dt="2024-09-09T17:17:39.151" v="2313" actId="1076"/>
-          <ac:spMkLst>
-            <pc:docMk/>
-            <pc:sldMk cId="2937310628" sldId="518"/>
-            <ac:spMk id="8" creationId="{D2191442-CF11-6727-AD70-A3FF401BDF4B}"/>
+            <ac:spMk id="7" creationId="{057761C0-6EFF-1A7C-37F4-0069E71372D6}"/>
           </ac:spMkLst>
         </pc:spChg>
       </pc:sldChg>
@@ -1808,7 +188,7 @@
 </file>
 
 <file path=ppt/diagrams/colors1.xml><?xml version="1.0" encoding="utf-8"?>
-<dgm:colorsDef xmlns:dgm="http://schemas.openxmlformats.org/drawingml/2006/diagram" xmlns:a="http://schemas.openxmlformats.org/drawingml/2006/main" uniqueId="urn:microsoft.com/office/officeart/2005/8/colors/colorful2">
+<dgm:colorsDef xmlns:dgm="http://schemas.openxmlformats.org/drawingml/2006/diagram" xmlns:a="http://schemas.openxmlformats.org/drawingml/2006/main" uniqueId="urn:microsoft.com/office/officeart/2005/8/colors/colorful2#1">
   <dgm:title val=""/>
   <dgm:desc val=""/>
   <dgm:catLst>
@@ -2590,7 +970,7 @@
 </file>
 
 <file path=ppt/diagrams/colors2.xml><?xml version="1.0" encoding="utf-8"?>
-<dgm:colorsDef xmlns:dgm="http://schemas.openxmlformats.org/drawingml/2006/diagram" xmlns:a="http://schemas.openxmlformats.org/drawingml/2006/main" uniqueId="urn:microsoft.com/office/officeart/2005/8/colors/colorful2">
+<dgm:colorsDef xmlns:dgm="http://schemas.openxmlformats.org/drawingml/2006/diagram" xmlns:a="http://schemas.openxmlformats.org/drawingml/2006/main" uniqueId="urn:microsoft.com/office/officeart/2005/8/colors/colorful2#2">
   <dgm:title val=""/>
   <dgm:desc val=""/>
   <dgm:catLst>
@@ -3375,7 +1755,7 @@
 <dgm:dataModel xmlns:dgm="http://schemas.openxmlformats.org/drawingml/2006/diagram" xmlns:a="http://schemas.openxmlformats.org/drawingml/2006/main">
   <dgm:ptLst>
     <dgm:pt modelId="{DDBF1F72-D5C6-45C1-8861-C60BF5F24714}" type="doc">
-      <dgm:prSet loTypeId="urn:microsoft.com/office/officeart/2005/8/layout/list1" loCatId="list" qsTypeId="urn:microsoft.com/office/officeart/2005/8/quickstyle/simple4" qsCatId="simple" csTypeId="urn:microsoft.com/office/officeart/2005/8/colors/colorful2" csCatId="colorful" phldr="1"/>
+      <dgm:prSet loTypeId="urn:microsoft.com/office/officeart/2005/8/layout/list1" loCatId="list" qsTypeId="urn:microsoft.com/office/officeart/2005/8/quickstyle/simple4#1" qsCatId="simple" csTypeId="urn:microsoft.com/office/officeart/2005/8/colors/colorful2#1" csCatId="colorful" phldr="1"/>
       <dgm:spPr/>
       <dgm:t>
         <a:bodyPr/>
@@ -3756,7 +2136,7 @@
 <dgm:dataModel xmlns:dgm="http://schemas.openxmlformats.org/drawingml/2006/diagram" xmlns:a="http://schemas.openxmlformats.org/drawingml/2006/main">
   <dgm:ptLst>
     <dgm:pt modelId="{DDBF1F72-D5C6-45C1-8861-C60BF5F24714}" type="doc">
-      <dgm:prSet loTypeId="urn:microsoft.com/office/officeart/2005/8/layout/list1" loCatId="list" qsTypeId="urn:microsoft.com/office/officeart/2005/8/quickstyle/simple4" qsCatId="simple" csTypeId="urn:microsoft.com/office/officeart/2005/8/colors/colorful2" csCatId="colorful" phldr="1"/>
+      <dgm:prSet loTypeId="urn:microsoft.com/office/officeart/2005/8/layout/list1" loCatId="list" qsTypeId="urn:microsoft.com/office/officeart/2005/8/quickstyle/simple4#2" qsCatId="simple" csTypeId="urn:microsoft.com/office/officeart/2005/8/colors/colorful2#2" csCatId="colorful" phldr="1"/>
       <dgm:spPr/>
       <dgm:t>
         <a:bodyPr/>
@@ -5603,7 +3983,7 @@
 </file>
 
 <file path=ppt/diagrams/quickStyle1.xml><?xml version="1.0" encoding="utf-8"?>
-<dgm:styleDef xmlns:dgm="http://schemas.openxmlformats.org/drawingml/2006/diagram" xmlns:a="http://schemas.openxmlformats.org/drawingml/2006/main" uniqueId="urn:microsoft.com/office/officeart/2005/8/quickstyle/simple4">
+<dgm:styleDef xmlns:dgm="http://schemas.openxmlformats.org/drawingml/2006/diagram" xmlns:a="http://schemas.openxmlformats.org/drawingml/2006/main" uniqueId="urn:microsoft.com/office/officeart/2005/8/quickstyle/simple4#1">
   <dgm:title val=""/>
   <dgm:desc val=""/>
   <dgm:catLst>
@@ -6637,7 +5017,7 @@
 </file>
 
 <file path=ppt/diagrams/quickStyle2.xml><?xml version="1.0" encoding="utf-8"?>
-<dgm:styleDef xmlns:dgm="http://schemas.openxmlformats.org/drawingml/2006/diagram" xmlns:a="http://schemas.openxmlformats.org/drawingml/2006/main" uniqueId="urn:microsoft.com/office/officeart/2005/8/quickstyle/simple4">
+<dgm:styleDef xmlns:dgm="http://schemas.openxmlformats.org/drawingml/2006/diagram" xmlns:a="http://schemas.openxmlformats.org/drawingml/2006/main" uniqueId="urn:microsoft.com/office/officeart/2005/8/quickstyle/simple4#2">
   <dgm:title val=""/>
   <dgm:desc val=""/>
   <dgm:catLst>
@@ -7752,7 +6132,7 @@
           <a:p>
             <a:fld id="{7C7E5181-6CF5-45F7-A87A-E0E0B1FD7549}" type="datetimeFigureOut">
               <a:rPr lang="en-US" smtClean="0"/>
-              <a:t>9/26/2026</a:t>
+              <a:t>9/28/2026</a:t>
             </a:fld>
             <a:endParaRPr lang="en-US"/>
           </a:p>
@@ -11299,7 +9679,15 @@
           <a:p>
             <a:r>
               <a:rPr lang="en-US" dirty="0"/>
-              <a:t>Here’s an actual example, from a couple of semesters ago, in Jest..</a:t>
+              <a:t>Here’s an actual example, from a couple of semesters ago, in </a:t>
+            </a:r>
+            <a:r>
+              <a:rPr lang="en-US" dirty="0" err="1"/>
+              <a:t>vitest</a:t>
+            </a:r>
+            <a:r>
+              <a:rPr lang="en-US" dirty="0"/>
+              <a:t>..</a:t>
             </a:r>
           </a:p>
           <a:p>
@@ -13716,7 +12104,7 @@
           <a:p>
             <a:fld id="{5D2A64DE-480B-420F-9649-4F8E696E08E0}" type="datetime1">
               <a:rPr lang="en-US" smtClean="0"/>
-              <a:t>9/26/2026</a:t>
+              <a:t>9/28/2026</a:t>
             </a:fld>
             <a:endParaRPr lang="en-US"/>
           </a:p>
@@ -13950,7 +12338,7 @@
           <a:p>
             <a:fld id="{0D3616D0-8311-4107-9726-6B805E7D05BA}" type="datetime1">
               <a:rPr lang="en-US" smtClean="0"/>
-              <a:t>9/26/2026</a:t>
+              <a:t>9/28/2026</a:t>
             </a:fld>
             <a:endParaRPr lang="en-US"/>
           </a:p>
@@ -14158,7 +12546,7 @@
           <a:p>
             <a:fld id="{3BC2557A-5C88-417A-A763-5AC779462A5F}" type="datetime1">
               <a:rPr lang="en-US" smtClean="0"/>
-              <a:t>9/26/2026</a:t>
+              <a:t>9/28/2026</a:t>
             </a:fld>
             <a:endParaRPr lang="en-US"/>
           </a:p>
@@ -14713,7 +13101,7 @@
           <a:p>
             <a:fld id="{07C7BFD4-467E-4EDE-93EA-052F5B39A4E5}" type="datetime1">
               <a:rPr lang="en-US" smtClean="0"/>
-              <a:t>9/26/2026</a:t>
+              <a:t>9/28/2026</a:t>
             </a:fld>
             <a:endParaRPr lang="en-US"/>
           </a:p>
@@ -15026,7 +13414,7 @@
           <a:p>
             <a:fld id="{A533CBE2-D5BE-47AC-ADC2-9CDFC1D0CF90}" type="datetime1">
               <a:rPr lang="en-US" smtClean="0"/>
-              <a:t>9/26/2026</a:t>
+              <a:t>9/28/2026</a:t>
             </a:fld>
             <a:endParaRPr lang="en-US"/>
           </a:p>
@@ -15327,7 +13715,7 @@
           <a:p>
             <a:fld id="{39B7EDB1-CE74-4951-85A2-0B01C2128E28}" type="datetime1">
               <a:rPr lang="en-US" smtClean="0"/>
-              <a:t>9/26/2026</a:t>
+              <a:t>9/28/2026</a:t>
             </a:fld>
             <a:endParaRPr lang="en-US"/>
           </a:p>
@@ -15775,7 +14163,7 @@
           <a:p>
             <a:fld id="{2BC7EB92-A5C2-4807-A9DC-9EDE6CBFB241}" type="datetime1">
               <a:rPr lang="en-US" smtClean="0"/>
-              <a:t>9/26/2026</a:t>
+              <a:t>9/28/2026</a:t>
             </a:fld>
             <a:endParaRPr lang="en-US"/>
           </a:p>
@@ -15921,7 +14309,7 @@
           <a:p>
             <a:fld id="{109E55A0-C911-4F03-82FC-7E5926047D46}" type="datetime1">
               <a:rPr lang="en-US" smtClean="0"/>
-              <a:t>9/26/2026</a:t>
+              <a:t>9/28/2026</a:t>
             </a:fld>
             <a:endParaRPr lang="en-US"/>
           </a:p>
@@ -16070,7 +14458,7 @@
           <a:p>
             <a:fld id="{2B7B7EE0-7771-4CD5-9B2B-3550753A54A1}" type="datetime1">
               <a:rPr lang="en-US" smtClean="0"/>
-              <a:t>9/26/2026</a:t>
+              <a:t>9/28/2026</a:t>
             </a:fld>
             <a:endParaRPr lang="en-US"/>
           </a:p>
@@ -16381,7 +14769,7 @@
           <a:p>
             <a:fld id="{F8B318B3-0E87-4416-A9B8-D891968C2727}" type="datetime1">
               <a:rPr lang="en-US" smtClean="0"/>
-              <a:t>9/26/2026</a:t>
+              <a:t>9/28/2026</a:t>
             </a:fld>
             <a:endParaRPr lang="en-US"/>
           </a:p>
@@ -16669,7 +15057,7 @@
           <a:p>
             <a:fld id="{EA476A42-A091-4468-A075-64A31BE59948}" type="datetime1">
               <a:rPr lang="en-US" smtClean="0"/>
-              <a:t>9/26/2026</a:t>
+              <a:t>9/28/2026</a:t>
             </a:fld>
             <a:endParaRPr lang="en-US"/>
           </a:p>
@@ -16910,7 +15298,7 @@
           <a:p>
             <a:fld id="{54D997E8-DDEE-43F1-8D9B-F8A1E11DE488}" type="datetime1">
               <a:rPr lang="en-US" smtClean="0"/>
-              <a:t>9/26/2026</a:t>
+              <a:t>9/28/2026</a:t>
             </a:fld>
             <a:endParaRPr lang="en-US"/>
           </a:p>
@@ -21045,7 +19433,7 @@
           </a:ln>
           <a:extLst>
             <a:ext uri="{C572A759-6A51-4108-AA02-DFA0A04FC94B}">
-              <ma14:wrappingTextBoxFlag xmlns="" xmlns:m="http://schemas.openxmlformats.org/officeDocument/2006/math" xmlns:a14="http://schemas.microsoft.com/office/drawing/2010/main" xmlns:ma14="http://schemas.microsoft.com/office/mac/drawingml/2011/main" val="1"/>
+              <ma14:wrappingTextBoxFlag xmlns:ma14="http://schemas.microsoft.com/office/mac/drawingml/2011/main" xmlns:a14="http://schemas.microsoft.com/office/drawing/2010/main" xmlns:m="http://schemas.openxmlformats.org/officeDocument/2006/math" xmlns="" val="1"/>
             </a:ext>
           </a:extLst>
         </p:spPr>
@@ -32528,7 +30916,15 @@
             </a:r>
             <a:r>
               <a:rPr lang="en-US" dirty="0"/>
-              <a:t>does in Jest</a:t>
+              <a:t>does in </a:t>
+            </a:r>
+            <a:r>
+              <a:rPr lang="en-US" dirty="0" err="1"/>
+              <a:t>vitest</a:t>
+            </a:r>
+            <a:r>
+              <a:rPr lang="en-US" dirty="0"/>
+              <a:t>.</a:t>
             </a:r>
           </a:p>
         </p:txBody>

</xml_diff>